<commit_message>
M16: Sim-Review umgesetzt (sim_review true, Inhalt aktualisiert)
Co-Authored-By: Claude Opus 4.8 <noreply@anthropic.com>
</commit_message>
<xml_diff>
--- a/protected-downloads/praesentation/M16.pptx
+++ b/protected-downloads/praesentation/M16.pptx
@@ -10190,7 +10190,7 @@
                 </a:solidFill>
                 <a:latin typeface="Consolas"/>
               </a:rPr>
-              <a:t>01:00       </a:t>
+              <a:t>01:03       </a:t>
             </a:r>
             <a:r>
               <a:rPr sz="1200" b="1">
@@ -10227,7 +10227,7 @@
                 </a:solidFill>
                 <a:latin typeface="Consolas"/>
               </a:rPr>
-              <a:t>01:05       </a:t>
+              <a:t>01:06       </a:t>
             </a:r>
             <a:r>
               <a:rPr sz="1200" b="1">
@@ -10264,7 +10264,7 @@
                 </a:solidFill>
                 <a:latin typeface="Consolas"/>
               </a:rPr>
-              <a:t>01:20       </a:t>
+              <a:t>01:23       </a:t>
             </a:r>
             <a:r>
               <a:rPr sz="1200" b="1">
@@ -10301,7 +10301,7 @@
                 </a:solidFill>
                 <a:latin typeface="Consolas"/>
               </a:rPr>
-              <a:t>01:30       </a:t>
+              <a:t>01:35       </a:t>
             </a:r>
             <a:r>
               <a:rPr sz="1200" b="1">
@@ -10338,7 +10338,7 @@
                 </a:solidFill>
                 <a:latin typeface="Consolas"/>
               </a:rPr>
-              <a:t>01:35       </a:t>
+              <a:t>01:40       </a:t>
             </a:r>
             <a:r>
               <a:rPr sz="1200" b="1">

</xml_diff>

<commit_message>
M-Track Batch 2: M16 Deck (Web/Workbook)
Co-Authored-By: Claude Fable 5 <noreply@anthropic.com>
</commit_message>
<xml_diff>
--- a/protected-downloads/praesentation/M16.pptx
+++ b/protected-downloads/praesentation/M16.pptx
@@ -588,7 +588,77 @@
           <a:lstStyle/>
           <a:p>
             <a:r>
-              <a:t>Siehe Trainerhandbuch (Sektion 3) für Moderationshinweise, Timing und erwartete Teilnehmerreaktionen.</a:t>
+              <a:t>Überleitung zum Maßnahmenplan und Selbstcheck.</a:t>
+            </a:r>
+          </a:p>
+        </p:txBody>
+      </p:sp>
+      <p:sp>
+        <p:nvSpPr>
+          <p:cNvPr id="4" name="Slide Number Placeholder 3"/>
+          <p:cNvSpPr>
+            <a:spLocks noGrp="1"/>
+          </p:cNvSpPr>
+          <p:nvPr>
+            <p:ph type="sldNum" idx="5" sz="quarter"/>
+          </p:nvPr>
+        </p:nvSpPr>
+        <p:spPr/>
+      </p:sp>
+    </p:spTree>
+  </p:cSld>
+  <p:clrMapOvr>
+    <a:masterClrMapping/>
+  </p:clrMapOvr>
+</p:notes>
+</file>
+
+<file path=ppt/notesSlides/notesSlide11.xml><?xml version="1.0" encoding="utf-8"?>
+<p:notes xmlns:a="http://schemas.openxmlformats.org/drawingml/2006/main" xmlns:p="http://schemas.openxmlformats.org/presentationml/2006/main" xmlns:r="http://schemas.openxmlformats.org/officeDocument/2006/relationships">
+  <p:cSld>
+    <p:spTree>
+      <p:nvGrpSpPr>
+        <p:cNvPr id="1" name=""/>
+        <p:cNvGrpSpPr/>
+        <p:nvPr/>
+      </p:nvGrpSpPr>
+      <p:grpSpPr>
+        <a:xfrm>
+          <a:off x="0" y="0"/>
+          <a:ext cx="0" cy="0"/>
+          <a:chOff x="0" y="0"/>
+          <a:chExt cx="0" cy="0"/>
+        </a:xfrm>
+      </p:grpSpPr>
+      <p:sp>
+        <p:nvSpPr>
+          <p:cNvPr id="2" name="Slide Image Placeholder 1"/>
+          <p:cNvSpPr>
+            <a:spLocks noGrp="1"/>
+          </p:cNvSpPr>
+          <p:nvPr>
+            <p:ph type="sldImg" idx="2"/>
+          </p:nvPr>
+        </p:nvSpPr>
+        <p:spPr/>
+      </p:sp>
+      <p:sp>
+        <p:nvSpPr>
+          <p:cNvPr id="3" name="Notes Placeholder 2"/>
+          <p:cNvSpPr>
+            <a:spLocks noGrp="1"/>
+          </p:cNvSpPr>
+          <p:nvPr>
+            <p:ph type="body" idx="3" sz="quarter"/>
+          </p:nvPr>
+        </p:nvSpPr>
+        <p:spPr/>
+        <p:txBody>
+          <a:bodyPr/>
+          <a:lstStyle/>
+          <a:p>
+            <a:r>
+              <a:t>Selbstcheck nach 4 Wochen als Transferanker.</a:t>
             </a:r>
           </a:p>
         </p:txBody>
@@ -658,7 +728,7 @@
           <a:lstStyle/>
           <a:p>
             <a:r>
-              <a:t>Siehe Trainerhandbuch (Sektion 3) für Moderationshinweise, Timing und erwartete Teilnehmerreaktionen.</a:t>
+              <a:t>Einstieg: „Welche Kennzahl nutzen Sie heute, um Ihren Bestand zu steuern?" Meist DB – die NMZ geht weiter.</a:t>
             </a:r>
           </a:p>
         </p:txBody>
@@ -728,7 +798,7 @@
           <a:lstStyle/>
           <a:p>
             <a:r>
-              <a:t>Siehe Trainerhandbuch (Sektion 3) für Moderationshinweise, Timing und erwartete Teilnehmerreaktionen.</a:t>
+              <a:t>Kernbotschaft: der DB kann trügen – ein margenstarker, aber risikoreicher Kunde ist auf NMZ-Basis oft unattraktiv.</a:t>
             </a:r>
           </a:p>
         </p:txBody>
@@ -798,7 +868,7 @@
           <a:lstStyle/>
           <a:p>
             <a:r>
-              <a:t>Siehe Trainerhandbuch (Sektion 3) für Moderationshinweise, Timing und erwartete Teilnehmerreaktionen.</a:t>
+              <a:t>Leseübung: ein NMZ-Ranking gemeinsam interpretieren – wo sitzt der Ertrag, wo die Verlustbringer?</a:t>
             </a:r>
           </a:p>
         </p:txBody>
@@ -868,7 +938,7 @@
           <a:lstStyle/>
           <a:p>
             <a:r>
-              <a:t>Siehe Trainerhandbuch (Sektion 3) für Moderationshinweise, Timing und erwartete Teilnehmerreaktionen.</a:t>
+              <a:t>Der Prozess funktioniert nur als Routine – 30 Minuten fest im Monatskalender.</a:t>
             </a:r>
           </a:p>
         </p:txBody>
@@ -938,7 +1008,7 @@
           <a:lstStyle/>
           <a:p>
             <a:r>
-              <a:t>Siehe Trainerhandbuch (Sektion 3) für Moderationshinweise, Timing und erwartete Teilnehmerreaktionen.</a:t>
+              <a:t>Nicht alle Verlustbringer gleich behandeln: manche haben einen klaren Hebel, andere sind Exit-Kandidaten.</a:t>
             </a:r>
           </a:p>
         </p:txBody>
@@ -1008,7 +1078,7 @@
           <a:lstStyle/>
           <a:p>
             <a:r>
-              <a:t>Siehe Trainerhandbuch (Sektion 3) für Moderationshinweise, Timing und erwartete Teilnehmerreaktionen.</a:t>
+              <a:t>Wenn der Kunde mit Sparkassen-Wechsel droht: ruhig bleiben, Gesamtpaket anbieten, im Zweifel Exit-Prüfung mit Bereichsleiter (M14).</a:t>
             </a:r>
           </a:p>
         </p:txBody>
@@ -1078,7 +1148,7 @@
           <a:lstStyle/>
           <a:p>
             <a:r>
-              <a:t>Siehe Trainerhandbuch (Sektion 3) für Moderationshinweise, Timing und erwartete Teilnehmerreaktionen.</a:t>
+              <a:t>Felix ist 0,29 Prozentpunkte unter Ziel. Sieben Kunden ziehen die Bestands-NMZ nach unten – dort liegt der Hebel.</a:t>
             </a:r>
           </a:p>
         </p:txBody>
@@ -1148,7 +1218,12 @@
           <a:lstStyle/>
           <a:p>
             <a:r>
-              <a:t>Siehe Trainerhandbuch (Sektion 3) für Moderationshinweise, Timing und erwartete Teilnehmerreaktionen.</a:t>
+              <a:t>AB Musterlösung (Trainer-Version)</a:t>
+            </a:r>
+          </a:p>
+          <a:p>
+            <a:r>
+              <a:t>Beispiel Metzger GmbH: NMZ −0,20 %, Rating D, Marge zu niedrig – Hebel Rating/Exit, nicht Konditionen. Ursachengerecht handeln, nicht pauschal.</a:t>
             </a:r>
           </a:p>
         </p:txBody>
@@ -4966,7 +5041,7 @@
                 </a:solidFill>
                 <a:latin typeface="Arial"/>
               </a:rPr>
-              <a:t>Schritt 1: Identifizieren (monatlich, 30 Minuten)</a:t>
+              <a:t>Schritt 1: identifizieren</a:t>
             </a:r>
           </a:p>
         </p:txBody>
@@ -4992,6 +5067,25 @@
             <a:spAutoFit/>
           </a:bodyPr>
           <a:lstStyle/>
+          <a:p>
+            <a:pPr marL="177800" indent="-177800">
+              <a:spcBef>
+                <a:spcPts val="600"/>
+              </a:spcBef>
+              <a:spcAft>
+                <a:spcPts val="200"/>
+              </a:spcAft>
+            </a:pPr>
+            <a:r>
+              <a:rPr sz="1200" i="1">
+                <a:solidFill>
+                  <a:srgbClr val="3D5466"/>
+                </a:solidFill>
+                <a:latin typeface="Arial"/>
+              </a:rPr>
+              <a:t>→  Dreißig Minuten im Monat genügen, um die Verlustbringer und die Hebel im Bestand zu finden.</a:t>
+            </a:r>
+          </a:p>
           <a:p>
             <a:pPr marL="190500" indent="-190500">
               <a:spcBef>
@@ -5008,7 +5102,26 @@
                 </a:solidFill>
                 <a:latin typeface="Arial"/>
               </a:rPr>
-              <a:t>▸  Einmal im Monat: agree-NMZ-Ranking aufrufen. Die fünf Kunden mit der niedrigsten NMZ markieren. Für jeden prüfen: Was ist die Hauptursache? (Marge? Kein Verbund? Rating? Betreuungskosten?)</a:t>
+              <a:t>▸  Monatlich das NMZ-Ranking aufrufen und die Kunden unter Benchmark markieren.</a:t>
+            </a:r>
+          </a:p>
+          <a:p>
+            <a:pPr marL="190500" indent="-190500">
+              <a:spcBef>
+                <a:spcPts val="400"/>
+              </a:spcBef>
+              <a:spcAft>
+                <a:spcPts val="200"/>
+              </a:spcAft>
+            </a:pPr>
+            <a:r>
+              <a:rPr sz="1300">
+                <a:solidFill>
+                  <a:srgbClr val="3D5466"/>
+                </a:solidFill>
+                <a:latin typeface="Arial"/>
+              </a:rPr>
+              <a:t>▸  Besonderes Augenmerk auf Kunden mit NMZ unter 0,5 % oder negativem DB.</a:t>
             </a:r>
           </a:p>
         </p:txBody>
@@ -5346,7 +5459,7 @@
                 </a:solidFill>
                 <a:latin typeface="Arial"/>
               </a:rPr>
-              <a:t>Schritt 2: Priorisieren</a:t>
+              <a:t>Schritt 2: priorisieren nach Hebel</a:t>
             </a:r>
           </a:p>
         </p:txBody>
@@ -5372,6 +5485,25 @@
             <a:spAutoFit/>
           </a:bodyPr>
           <a:lstStyle/>
+          <a:p>
+            <a:pPr marL="177800" indent="-177800">
+              <a:spcBef>
+                <a:spcPts val="600"/>
+              </a:spcBef>
+              <a:spcAft>
+                <a:spcPts val="200"/>
+              </a:spcAft>
+            </a:pPr>
+            <a:r>
+              <a:rPr sz="1200" i="1">
+                <a:solidFill>
+                  <a:srgbClr val="3D5466"/>
+                </a:solidFill>
+                <a:latin typeface="Arial"/>
+              </a:rPr>
+              <a:t>→  Die drei Kunden mit dem größten Hebel schlagen zwanzig Aktionen ohne Fokus.</a:t>
+            </a:r>
+          </a:p>
           <a:p>
             <a:pPr marL="190500" indent="-190500">
               <a:spcBef>
@@ -5388,7 +5520,7 @@
                 </a:solidFill>
                 <a:latin typeface="Arial"/>
               </a:rPr>
-              <a:t>▸  Nicht alle fünf auf einmal angehen. Priorisierung nach zwei Kriterien:</a:t>
+              <a:t>▸  Je Kunde die Hauptursache bestimmen: Konditionen, Rating, Cross-Selling-Lücke, Risikokosten.</a:t>
             </a:r>
           </a:p>
           <a:p>
@@ -5407,45 +5539,7 @@
                 </a:solidFill>
                 <a:latin typeface="Arial"/>
               </a:rPr>
-              <a:t>▸  Potenzial der Verbesserung: Wie stark könnte sich die NMZ verbessern?</a:t>
-            </a:r>
-          </a:p>
-          <a:p>
-            <a:pPr marL="190500" indent="-190500">
-              <a:spcBef>
-                <a:spcPts val="400"/>
-              </a:spcBef>
-              <a:spcAft>
-                <a:spcPts val="200"/>
-              </a:spcAft>
-            </a:pPr>
-            <a:r>
-              <a:rPr sz="1300">
-                <a:solidFill>
-                  <a:srgbClr val="3D5466"/>
-                </a:solidFill>
-                <a:latin typeface="Arial"/>
-              </a:rPr>
-              <a:t>▸  Hebelverfügbarkeit: Wie schnell und einfach lässt sich der Hebel aktivieren?</a:t>
-            </a:r>
-          </a:p>
-          <a:p>
-            <a:pPr marL="190500" indent="-190500">
-              <a:spcBef>
-                <a:spcPts val="400"/>
-              </a:spcBef>
-              <a:spcAft>
-                <a:spcPts val="200"/>
-              </a:spcAft>
-            </a:pPr>
-            <a:r>
-              <a:rPr sz="1300">
-                <a:solidFill>
-                  <a:srgbClr val="3D5466"/>
-                </a:solidFill>
-                <a:latin typeface="Arial"/>
-              </a:rPr>
-              <a:t>▸  Einfache Priorisierungsmatrix:</a:t>
+              <a:t>▸  Nach Hebelgröße sortieren – wo bringt eine Maßnahme den meisten NMZ-Zuwachs?</a:t>
             </a:r>
           </a:p>
         </p:txBody>
@@ -5561,7 +5655,7 @@
             <a:avLst/>
           </a:prstGeom>
           <a:solidFill>
-            <a:srgbClr val="FFFFFF"/>
+            <a:srgbClr val="EDEDF3"/>
           </a:solidFill>
           <a:ln>
             <a:noFill/>
@@ -5662,43 +5756,51 @@
                 </a:solidFill>
                 <a:latin typeface="Consolas"/>
               </a:rPr>
-              <a:t>M16  ·  ÜBERSICHT</a:t>
-            </a:r>
-          </a:p>
-        </p:txBody>
-      </p:sp>
-      <p:sp>
-        <p:nvSpPr>
-          <p:cNvPr id="5" name="TextBox 4"/>
-          <p:cNvSpPr txBox="1"/>
-          <p:nvPr/>
-        </p:nvSpPr>
-        <p:spPr>
-          <a:xfrm>
-            <a:off x="685800" y="502920"/>
-            <a:ext cx="10817352" cy="594360"/>
-          </a:xfrm>
-          <a:prstGeom prst="rect">
-            <a:avLst/>
-          </a:prstGeom>
-          <a:noFill/>
-        </p:spPr>
-        <p:txBody>
-          <a:bodyPr wrap="square">
-            <a:spAutoFit/>
-          </a:bodyPr>
-          <a:lstStyle/>
-          <a:p>
-            <a:pPr algn="l"/>
-            <a:r>
-              <a:rPr sz="2000" b="1" i="0">
-                <a:solidFill>
-                  <a:srgbClr val="1F2C56"/>
-                </a:solidFill>
-                <a:latin typeface="Arial"/>
-              </a:rPr>
-              <a:t>Schritt 2: Priorisieren</a:t>
-            </a:r>
+              <a:t>M16  ·  INHALT</a:t>
+            </a:r>
+          </a:p>
+        </p:txBody>
+      </p:sp>
+      <p:sp>
+        <p:nvSpPr>
+          <p:cNvPr id="5" name="Rectangle 4"/>
+          <p:cNvSpPr/>
+          <p:nvPr/>
+        </p:nvSpPr>
+        <p:spPr>
+          <a:xfrm>
+            <a:off x="0" y="1234440"/>
+            <a:ext cx="12188952" cy="12700"/>
+          </a:xfrm>
+          <a:prstGeom prst="rect">
+            <a:avLst/>
+          </a:prstGeom>
+          <a:solidFill>
+            <a:srgbClr val="D8DFE4"/>
+          </a:solidFill>
+          <a:ln>
+            <a:noFill/>
+          </a:ln>
+        </p:spPr>
+        <p:style>
+          <a:lnRef idx="1">
+            <a:schemeClr val="accent1"/>
+          </a:lnRef>
+          <a:fillRef idx="3">
+            <a:schemeClr val="accent1"/>
+          </a:fillRef>
+          <a:effectRef idx="2">
+            <a:schemeClr val="accent1"/>
+          </a:effectRef>
+          <a:fontRef idx="minor">
+            <a:schemeClr val="lt1"/>
+          </a:fontRef>
+        </p:style>
+        <p:txBody>
+          <a:bodyPr rtlCol="0" anchor="ctr"/>
+          <a:lstStyle/>
+          <a:p>
+            <a:pPr algn="ctr"/>
           </a:p>
         </p:txBody>
       </p:sp>
@@ -5710,8 +5812,8 @@
         </p:nvSpPr>
         <p:spPr>
           <a:xfrm>
-            <a:off x="685800" y="1143000"/>
-            <a:ext cx="10817352" cy="25400"/>
+            <a:off x="685800" y="502920"/>
+            <a:ext cx="36576" cy="658368"/>
           </a:xfrm>
           <a:prstGeom prst="rect">
             <a:avLst/>
@@ -5745,6 +5847,660 @@
           </a:p>
         </p:txBody>
       </p:sp>
+      <p:sp>
+        <p:nvSpPr>
+          <p:cNvPr id="7" name="TextBox 6"/>
+          <p:cNvSpPr txBox="1"/>
+          <p:nvPr/>
+        </p:nvSpPr>
+        <p:spPr>
+          <a:xfrm>
+            <a:off x="813816" y="502920"/>
+            <a:ext cx="10634472" cy="685800"/>
+          </a:xfrm>
+          <a:prstGeom prst="rect">
+            <a:avLst/>
+          </a:prstGeom>
+          <a:noFill/>
+        </p:spPr>
+        <p:txBody>
+          <a:bodyPr wrap="square">
+            <a:spAutoFit/>
+          </a:bodyPr>
+          <a:lstStyle/>
+          <a:p>
+            <a:pPr algn="l"/>
+            <a:r>
+              <a:rPr sz="2400" b="1" i="0">
+                <a:solidFill>
+                  <a:srgbClr val="1F2C56"/>
+                </a:solidFill>
+                <a:latin typeface="Arial"/>
+              </a:rPr>
+              <a:t>Schritt 3: handeln und dokumentieren</a:t>
+            </a:r>
+          </a:p>
+        </p:txBody>
+      </p:sp>
+      <p:sp>
+        <p:nvSpPr>
+          <p:cNvPr id="8" name="TextBox 7"/>
+          <p:cNvSpPr txBox="1"/>
+          <p:nvPr/>
+        </p:nvSpPr>
+        <p:spPr>
+          <a:xfrm>
+            <a:off x="685800" y="1417320"/>
+            <a:ext cx="10817352" cy="4892040"/>
+          </a:xfrm>
+          <a:prstGeom prst="rect">
+            <a:avLst/>
+          </a:prstGeom>
+          <a:noFill/>
+        </p:spPr>
+        <p:txBody>
+          <a:bodyPr wrap="square" anchor="ctr">
+            <a:spAutoFit/>
+          </a:bodyPr>
+          <a:lstStyle/>
+          <a:p>
+            <a:pPr marL="177800" indent="-177800">
+              <a:spcBef>
+                <a:spcPts val="600"/>
+              </a:spcBef>
+              <a:spcAft>
+                <a:spcPts val="200"/>
+              </a:spcAft>
+            </a:pPr>
+            <a:r>
+              <a:rPr sz="1200" i="1">
+                <a:solidFill>
+                  <a:srgbClr val="3D5466"/>
+                </a:solidFill>
+                <a:latin typeface="Arial"/>
+              </a:rPr>
+              <a:t>→  Eine erkannte NMZ-Lücke ist erst geschlossen, wenn die Maßnahme umgesetzt und dokumentiert ist.</a:t>
+            </a:r>
+          </a:p>
+          <a:p>
+            <a:pPr marL="190500" indent="-190500">
+              <a:spcBef>
+                <a:spcPts val="400"/>
+              </a:spcBef>
+              <a:spcAft>
+                <a:spcPts val="200"/>
+              </a:spcAft>
+            </a:pPr>
+            <a:r>
+              <a:rPr sz="1300">
+                <a:solidFill>
+                  <a:srgbClr val="3D5466"/>
+                </a:solidFill>
+                <a:latin typeface="Arial"/>
+              </a:rPr>
+              <a:t>▸  Je nach Ursache: Konditionen anpassen, Cross-Selling, Rating verbessern oder Exit prüfen.</a:t>
+            </a:r>
+          </a:p>
+          <a:p>
+            <a:pPr marL="190500" indent="-190500">
+              <a:spcBef>
+                <a:spcPts val="400"/>
+              </a:spcBef>
+              <a:spcAft>
+                <a:spcPts val="200"/>
+              </a:spcAft>
+            </a:pPr>
+            <a:r>
+              <a:rPr sz="1300">
+                <a:solidFill>
+                  <a:srgbClr val="3D5466"/>
+                </a:solidFill>
+                <a:latin typeface="Arial"/>
+              </a:rPr>
+              <a:t>▸  Maßnahme, Verantwortlichen und Termin im System festhalten.</a:t>
+            </a:r>
+          </a:p>
+        </p:txBody>
+      </p:sp>
+      <p:sp>
+        <p:nvSpPr>
+          <p:cNvPr id="9" name="Rectangle 8"/>
+          <p:cNvSpPr/>
+          <p:nvPr/>
+        </p:nvSpPr>
+        <p:spPr>
+          <a:xfrm>
+            <a:off x="0" y="6510528"/>
+            <a:ext cx="12188952" cy="347472"/>
+          </a:xfrm>
+          <a:prstGeom prst="rect">
+            <a:avLst/>
+          </a:prstGeom>
+          <a:solidFill>
+            <a:srgbClr val="0A1937"/>
+          </a:solidFill>
+          <a:ln>
+            <a:noFill/>
+          </a:ln>
+        </p:spPr>
+        <p:style>
+          <a:lnRef idx="1">
+            <a:schemeClr val="accent1"/>
+          </a:lnRef>
+          <a:fillRef idx="3">
+            <a:schemeClr val="accent1"/>
+          </a:fillRef>
+          <a:effectRef idx="2">
+            <a:schemeClr val="accent1"/>
+          </a:effectRef>
+          <a:fontRef idx="minor">
+            <a:schemeClr val="lt1"/>
+          </a:fontRef>
+        </p:style>
+        <p:txBody>
+          <a:bodyPr rtlCol="0" anchor="ctr"/>
+          <a:lstStyle/>
+          <a:p>
+            <a:pPr algn="ctr"/>
+          </a:p>
+        </p:txBody>
+      </p:sp>
+      <p:sp>
+        <p:nvSpPr>
+          <p:cNvPr id="10" name="TextBox 9"/>
+          <p:cNvSpPr txBox="1"/>
+          <p:nvPr/>
+        </p:nvSpPr>
+        <p:spPr>
+          <a:xfrm>
+            <a:off x="685800" y="6583680"/>
+            <a:ext cx="6490411" cy="256032"/>
+          </a:xfrm>
+          <a:prstGeom prst="rect">
+            <a:avLst/>
+          </a:prstGeom>
+          <a:noFill/>
+        </p:spPr>
+        <p:txBody>
+          <a:bodyPr wrap="none">
+            <a:spAutoFit/>
+          </a:bodyPr>
+          <a:lstStyle/>
+          <a:p>
+            <a:pPr algn="l"/>
+            <a:r>
+              <a:rPr sz="700">
+                <a:solidFill>
+                  <a:srgbClr val="A0B4D2"/>
+                </a:solidFill>
+                <a:latin typeface="Consolas"/>
+              </a:rPr>
+              <a:t>FKB Campus  ·  M16</a:t>
+            </a:r>
+          </a:p>
+        </p:txBody>
+      </p:sp>
+    </p:spTree>
+  </p:cSld>
+  <p:clrMapOvr>
+    <a:masterClrMapping/>
+  </p:clrMapOvr>
+</p:sld>
+</file>
+
+<file path=ppt/slides/slide13.xml><?xml version="1.0" encoding="utf-8"?>
+<p:sld xmlns:a="http://schemas.openxmlformats.org/drawingml/2006/main" xmlns:p="http://schemas.openxmlformats.org/presentationml/2006/main" xmlns:r="http://schemas.openxmlformats.org/officeDocument/2006/relationships">
+  <p:cSld>
+    <p:spTree>
+      <p:nvGrpSpPr>
+        <p:cNvPr id="1" name=""/>
+        <p:cNvGrpSpPr/>
+        <p:nvPr/>
+      </p:nvGrpSpPr>
+      <p:grpSpPr/>
+      <p:sp>
+        <p:nvSpPr>
+          <p:cNvPr id="2" name="Rectangle 1"/>
+          <p:cNvSpPr/>
+          <p:nvPr/>
+        </p:nvSpPr>
+        <p:spPr>
+          <a:xfrm>
+            <a:off x="0" y="0"/>
+            <a:ext cx="12188952" cy="6858000"/>
+          </a:xfrm>
+          <a:prstGeom prst="rect">
+            <a:avLst/>
+          </a:prstGeom>
+          <a:solidFill>
+            <a:srgbClr val="1F2C56"/>
+          </a:solidFill>
+          <a:ln>
+            <a:noFill/>
+          </a:ln>
+        </p:spPr>
+        <p:style>
+          <a:lnRef idx="1">
+            <a:schemeClr val="accent1"/>
+          </a:lnRef>
+          <a:fillRef idx="3">
+            <a:schemeClr val="accent1"/>
+          </a:fillRef>
+          <a:effectRef idx="2">
+            <a:schemeClr val="accent1"/>
+          </a:effectRef>
+          <a:fontRef idx="minor">
+            <a:schemeClr val="lt1"/>
+          </a:fontRef>
+        </p:style>
+        <p:txBody>
+          <a:bodyPr rtlCol="0" anchor="ctr"/>
+          <a:lstStyle/>
+          <a:p>
+            <a:pPr algn="ctr"/>
+          </a:p>
+        </p:txBody>
+      </p:sp>
+      <p:sp>
+        <p:nvSpPr>
+          <p:cNvPr id="3" name="TextBox 2"/>
+          <p:cNvSpPr txBox="1"/>
+          <p:nvPr/>
+        </p:nvSpPr>
+        <p:spPr>
+          <a:xfrm>
+            <a:off x="685800" y="2377440"/>
+            <a:ext cx="10817352" cy="365760"/>
+          </a:xfrm>
+          <a:prstGeom prst="rect">
+            <a:avLst/>
+          </a:prstGeom>
+          <a:noFill/>
+        </p:spPr>
+        <p:txBody>
+          <a:bodyPr wrap="none">
+            <a:spAutoFit/>
+          </a:bodyPr>
+          <a:lstStyle/>
+          <a:p>
+            <a:pPr algn="l"/>
+            <a:r>
+              <a:rPr sz="1200">
+                <a:solidFill>
+                  <a:srgbClr val="D9C089"/>
+                </a:solidFill>
+                <a:latin typeface="Consolas"/>
+              </a:rPr>
+              <a:t>FALLARBEIT</a:t>
+            </a:r>
+          </a:p>
+        </p:txBody>
+      </p:sp>
+      <p:sp>
+        <p:nvSpPr>
+          <p:cNvPr id="4" name="Rectangle 3"/>
+          <p:cNvSpPr/>
+          <p:nvPr/>
+        </p:nvSpPr>
+        <p:spPr>
+          <a:xfrm>
+            <a:off x="685800" y="2788920"/>
+            <a:ext cx="548640" cy="38100"/>
+          </a:xfrm>
+          <a:prstGeom prst="rect">
+            <a:avLst/>
+          </a:prstGeom>
+          <a:solidFill>
+            <a:srgbClr val="D9C089"/>
+          </a:solidFill>
+          <a:ln>
+            <a:noFill/>
+          </a:ln>
+        </p:spPr>
+        <p:style>
+          <a:lnRef idx="1">
+            <a:schemeClr val="accent1"/>
+          </a:lnRef>
+          <a:fillRef idx="3">
+            <a:schemeClr val="accent1"/>
+          </a:fillRef>
+          <a:effectRef idx="2">
+            <a:schemeClr val="accent1"/>
+          </a:effectRef>
+          <a:fontRef idx="minor">
+            <a:schemeClr val="lt1"/>
+          </a:fontRef>
+        </p:style>
+        <p:txBody>
+          <a:bodyPr rtlCol="0" anchor="ctr"/>
+          <a:lstStyle/>
+          <a:p>
+            <a:pPr algn="ctr"/>
+          </a:p>
+        </p:txBody>
+      </p:sp>
+      <p:sp>
+        <p:nvSpPr>
+          <p:cNvPr id="5" name="TextBox 4"/>
+          <p:cNvSpPr txBox="1"/>
+          <p:nvPr/>
+        </p:nvSpPr>
+        <p:spPr>
+          <a:xfrm>
+            <a:off x="685800" y="3017520"/>
+            <a:ext cx="10817352" cy="1463040"/>
+          </a:xfrm>
+          <a:prstGeom prst="rect">
+            <a:avLst/>
+          </a:prstGeom>
+          <a:noFill/>
+        </p:spPr>
+        <p:txBody>
+          <a:bodyPr wrap="square">
+            <a:spAutoFit/>
+          </a:bodyPr>
+          <a:lstStyle/>
+          <a:p>
+            <a:pPr algn="l"/>
+            <a:r>
+              <a:rPr sz="4000" b="1" i="0">
+                <a:solidFill>
+                  <a:srgbClr val="FFFFFF"/>
+                </a:solidFill>
+                <a:latin typeface="Arial"/>
+              </a:rPr>
+              <a:t>Praxiscase Felix Braun</a:t>
+            </a:r>
+          </a:p>
+        </p:txBody>
+      </p:sp>
+      <p:sp>
+        <p:nvSpPr>
+          <p:cNvPr id="6" name="TextBox 5"/>
+          <p:cNvSpPr txBox="1"/>
+          <p:nvPr/>
+        </p:nvSpPr>
+        <p:spPr>
+          <a:xfrm>
+            <a:off x="685800" y="4480560"/>
+            <a:ext cx="8653881" cy="1280160"/>
+          </a:xfrm>
+          <a:prstGeom prst="rect">
+            <a:avLst/>
+          </a:prstGeom>
+          <a:noFill/>
+        </p:spPr>
+        <p:txBody>
+          <a:bodyPr wrap="square">
+            <a:spAutoFit/>
+          </a:bodyPr>
+          <a:lstStyle/>
+          <a:p>
+            <a:pPr algn="l"/>
+            <a:r>
+              <a:rPr sz="1600" b="0" i="0">
+                <a:solidFill>
+                  <a:srgbClr val="C8D2E6"/>
+                </a:solidFill>
+                <a:latin typeface="Arial"/>
+              </a:rPr>
+              <a:t>Ein Maßnahmenpaket entwickeln, das die Bestands-NMZ zum Benchmark bringt.</a:t>
+            </a:r>
+          </a:p>
+        </p:txBody>
+      </p:sp>
+      <p:sp>
+        <p:nvSpPr>
+          <p:cNvPr id="7" name="TextBox 6"/>
+          <p:cNvSpPr txBox="1"/>
+          <p:nvPr/>
+        </p:nvSpPr>
+        <p:spPr>
+          <a:xfrm>
+            <a:off x="685800" y="6355080"/>
+            <a:ext cx="10817352" cy="274320"/>
+          </a:xfrm>
+          <a:prstGeom prst="rect">
+            <a:avLst/>
+          </a:prstGeom>
+          <a:noFill/>
+        </p:spPr>
+        <p:txBody>
+          <a:bodyPr wrap="none">
+            <a:spAutoFit/>
+          </a:bodyPr>
+          <a:lstStyle/>
+          <a:p>
+            <a:pPr algn="l"/>
+            <a:r>
+              <a:rPr sz="700">
+                <a:solidFill>
+                  <a:srgbClr val="8CA0C3"/>
+                </a:solidFill>
+                <a:latin typeface="Consolas"/>
+              </a:rPr>
+              <a:t>FKB Campus  ·  M16</a:t>
+            </a:r>
+          </a:p>
+        </p:txBody>
+      </p:sp>
+    </p:spTree>
+  </p:cSld>
+  <p:clrMapOvr>
+    <a:masterClrMapping/>
+  </p:clrMapOvr>
+</p:sld>
+</file>
+
+<file path=ppt/slides/slide14.xml><?xml version="1.0" encoding="utf-8"?>
+<p:sld xmlns:a="http://schemas.openxmlformats.org/drawingml/2006/main" xmlns:p="http://schemas.openxmlformats.org/presentationml/2006/main" xmlns:r="http://schemas.openxmlformats.org/officeDocument/2006/relationships">
+  <p:cSld>
+    <p:spTree>
+      <p:nvGrpSpPr>
+        <p:cNvPr id="1" name=""/>
+        <p:cNvGrpSpPr/>
+        <p:nvPr/>
+      </p:nvGrpSpPr>
+      <p:grpSpPr/>
+      <p:sp>
+        <p:nvSpPr>
+          <p:cNvPr id="2" name="Rectangle 1"/>
+          <p:cNvSpPr/>
+          <p:nvPr/>
+        </p:nvSpPr>
+        <p:spPr>
+          <a:xfrm>
+            <a:off x="0" y="0"/>
+            <a:ext cx="12188952" cy="6858000"/>
+          </a:xfrm>
+          <a:prstGeom prst="rect">
+            <a:avLst/>
+          </a:prstGeom>
+          <a:solidFill>
+            <a:srgbClr val="FFFFFF"/>
+          </a:solidFill>
+          <a:ln>
+            <a:noFill/>
+          </a:ln>
+        </p:spPr>
+        <p:style>
+          <a:lnRef idx="1">
+            <a:schemeClr val="accent1"/>
+          </a:lnRef>
+          <a:fillRef idx="3">
+            <a:schemeClr val="accent1"/>
+          </a:fillRef>
+          <a:effectRef idx="2">
+            <a:schemeClr val="accent1"/>
+          </a:effectRef>
+          <a:fontRef idx="minor">
+            <a:schemeClr val="lt1"/>
+          </a:fontRef>
+        </p:style>
+        <p:txBody>
+          <a:bodyPr rtlCol="0" anchor="ctr"/>
+          <a:lstStyle/>
+          <a:p>
+            <a:pPr algn="ctr"/>
+          </a:p>
+        </p:txBody>
+      </p:sp>
+      <p:sp>
+        <p:nvSpPr>
+          <p:cNvPr id="3" name="Rectangle 2"/>
+          <p:cNvSpPr/>
+          <p:nvPr/>
+        </p:nvSpPr>
+        <p:spPr>
+          <a:xfrm>
+            <a:off x="0" y="0"/>
+            <a:ext cx="12188952" cy="50292"/>
+          </a:xfrm>
+          <a:prstGeom prst="rect">
+            <a:avLst/>
+          </a:prstGeom>
+          <a:solidFill>
+            <a:srgbClr val="1F2C56"/>
+          </a:solidFill>
+          <a:ln>
+            <a:noFill/>
+          </a:ln>
+        </p:spPr>
+        <p:style>
+          <a:lnRef idx="1">
+            <a:schemeClr val="accent1"/>
+          </a:lnRef>
+          <a:fillRef idx="3">
+            <a:schemeClr val="accent1"/>
+          </a:fillRef>
+          <a:effectRef idx="2">
+            <a:schemeClr val="accent1"/>
+          </a:effectRef>
+          <a:fontRef idx="minor">
+            <a:schemeClr val="lt1"/>
+          </a:fontRef>
+        </p:style>
+        <p:txBody>
+          <a:bodyPr rtlCol="0" anchor="ctr"/>
+          <a:lstStyle/>
+          <a:p>
+            <a:pPr algn="ctr"/>
+          </a:p>
+        </p:txBody>
+      </p:sp>
+      <p:sp>
+        <p:nvSpPr>
+          <p:cNvPr id="4" name="TextBox 3"/>
+          <p:cNvSpPr txBox="1"/>
+          <p:nvPr/>
+        </p:nvSpPr>
+        <p:spPr>
+          <a:xfrm>
+            <a:off x="685800" y="109728"/>
+            <a:ext cx="10817352" cy="228600"/>
+          </a:xfrm>
+          <a:prstGeom prst="rect">
+            <a:avLst/>
+          </a:prstGeom>
+          <a:noFill/>
+        </p:spPr>
+        <p:txBody>
+          <a:bodyPr wrap="none">
+            <a:spAutoFit/>
+          </a:bodyPr>
+          <a:lstStyle/>
+          <a:p>
+            <a:pPr algn="l"/>
+            <a:r>
+              <a:rPr sz="750">
+                <a:solidFill>
+                  <a:srgbClr val="78808C"/>
+                </a:solidFill>
+                <a:latin typeface="Consolas"/>
+              </a:rPr>
+              <a:t>M16  ·  ÜBERSICHT</a:t>
+            </a:r>
+          </a:p>
+        </p:txBody>
+      </p:sp>
+      <p:sp>
+        <p:nvSpPr>
+          <p:cNvPr id="5" name="TextBox 4"/>
+          <p:cNvSpPr txBox="1"/>
+          <p:nvPr/>
+        </p:nvSpPr>
+        <p:spPr>
+          <a:xfrm>
+            <a:off x="685800" y="502920"/>
+            <a:ext cx="10817352" cy="594360"/>
+          </a:xfrm>
+          <a:prstGeom prst="rect">
+            <a:avLst/>
+          </a:prstGeom>
+          <a:noFill/>
+        </p:spPr>
+        <p:txBody>
+          <a:bodyPr wrap="square">
+            <a:spAutoFit/>
+          </a:bodyPr>
+          <a:lstStyle/>
+          <a:p>
+            <a:pPr algn="l"/>
+            <a:r>
+              <a:rPr sz="2000" b="1" i="0">
+                <a:solidFill>
+                  <a:srgbClr val="1F2C56"/>
+                </a:solidFill>
+                <a:latin typeface="Arial"/>
+              </a:rPr>
+              <a:t>Felix Braun: Ausgangslage im Bestand</a:t>
+            </a:r>
+          </a:p>
+        </p:txBody>
+      </p:sp>
+      <p:sp>
+        <p:nvSpPr>
+          <p:cNvPr id="6" name="Rectangle 5"/>
+          <p:cNvSpPr/>
+          <p:nvPr/>
+        </p:nvSpPr>
+        <p:spPr>
+          <a:xfrm>
+            <a:off x="685800" y="1143000"/>
+            <a:ext cx="10817352" cy="25400"/>
+          </a:xfrm>
+          <a:prstGeom prst="rect">
+            <a:avLst/>
+          </a:prstGeom>
+          <a:solidFill>
+            <a:srgbClr val="D9C089"/>
+          </a:solidFill>
+          <a:ln>
+            <a:noFill/>
+          </a:ln>
+        </p:spPr>
+        <p:style>
+          <a:lnRef idx="1">
+            <a:schemeClr val="accent1"/>
+          </a:lnRef>
+          <a:fillRef idx="3">
+            <a:schemeClr val="accent1"/>
+          </a:fillRef>
+          <a:effectRef idx="2">
+            <a:schemeClr val="accent1"/>
+          </a:effectRef>
+          <a:fontRef idx="minor">
+            <a:schemeClr val="lt1"/>
+          </a:fontRef>
+        </p:style>
+        <p:txBody>
+          <a:bodyPr rtlCol="0" anchor="ctr"/>
+          <a:lstStyle/>
+          <a:p>
+            <a:pPr algn="ctr"/>
+          </a:p>
+        </p:txBody>
+      </p:sp>
       <p:graphicFrame>
         <p:nvGraphicFramePr>
           <p:cNvPr id="7" name="Table 6"/>
@@ -5755,7 +6511,7 @@
         </p:nvGraphicFramePr>
         <p:xfrm>
           <a:off x="685800" y="1417320"/>
-          <a:ext cx="10817352" cy="1152144"/>
+          <a:ext cx="10817352" cy="1536192"/>
         </p:xfrm>
         <a:graphic>
           <a:graphicData uri="http://schemas.openxmlformats.org/drawingml/2006/table">
@@ -5773,18 +6529,6 @@
                   <a:txBody>
                     <a:bodyPr/>
                     <a:lstStyle/>
-                    <a:p/>
-                  </a:txBody>
-                  <a:tcPr>
-                    <a:solidFill>
-                      <a:srgbClr val="1F2C56"/>
-                    </a:solidFill>
-                  </a:tcPr>
-                </a:tc>
-                <a:tc>
-                  <a:txBody>
-                    <a:bodyPr/>
-                    <a:lstStyle/>
                     <a:p>
                       <a:r>
                         <a:rPr sz="1100" b="1">
@@ -5793,7 +6537,7 @@
                           </a:solidFill>
                           <a:latin typeface="Arial"/>
                         </a:rPr>
-                        <a:t>Schnell umsetzbar</a:t>
+                        <a:t>Größe</a:t>
                       </a:r>
                     </a:p>
                   </a:txBody>
@@ -5815,7 +6559,29 @@
                           </a:solidFill>
                           <a:latin typeface="Arial"/>
                         </a:rPr>
-                        <a:t>Langfristig</a:t>
+                        <a:t>Wert</a:t>
+                      </a:r>
+                    </a:p>
+                  </a:txBody>
+                  <a:tcPr>
+                    <a:solidFill>
+                      <a:srgbClr val="1F2C56"/>
+                    </a:solidFill>
+                  </a:tcPr>
+                </a:tc>
+                <a:tc>
+                  <a:txBody>
+                    <a:bodyPr/>
+                    <a:lstStyle/>
+                    <a:p>
+                      <a:r>
+                        <a:rPr sz="1100" b="1">
+                          <a:solidFill>
+                            <a:srgbClr val="FFFFFF"/>
+                          </a:solidFill>
+                          <a:latin typeface="Arial"/>
+                        </a:rPr>
+                        <a:t>Ziel/Hebel</a:t>
                       </a:r>
                     </a:p>
                   </a:txBody>
@@ -5839,7 +6605,7 @@
                           </a:solidFill>
                           <a:latin typeface="Arial"/>
                         </a:rPr>
-                        <a:t>Hohes Verbesserungspotenzial</a:t>
+                        <a:t>Bestands-NMZ</a:t>
                       </a:r>
                     </a:p>
                   </a:txBody>
@@ -5857,7 +6623,7 @@
                           </a:solidFill>
                           <a:latin typeface="Arial"/>
                         </a:rPr>
-                        <a:t>Sofort angehen (Prio 1)</a:t>
+                        <a:t>0,81 %</a:t>
                       </a:r>
                     </a:p>
                   </a:txBody>
@@ -5875,7 +6641,7 @@
                           </a:solidFill>
                           <a:latin typeface="Arial"/>
                         </a:rPr>
-                        <a:t>Mittelfristig planen (Prio 2)</a:t>
+                        <a:t>Benchmark 1,10 %</a:t>
                       </a:r>
                     </a:p>
                   </a:txBody>
@@ -5895,7 +6661,7 @@
                           </a:solidFill>
                           <a:latin typeface="Arial"/>
                         </a:rPr>
-                        <a:t>Niedriges Verbesserungspotenzial</a:t>
+                        <a:t>Kunden gesamt</a:t>
                       </a:r>
                     </a:p>
                   </a:txBody>
@@ -5913,7 +6679,7 @@
                           </a:solidFill>
                           <a:latin typeface="Arial"/>
                         </a:rPr>
-                        <a:t>Opportunistisch (Prio 3)</a:t>
+                        <a:t>42</a:t>
                       </a:r>
                     </a:p>
                   </a:txBody>
@@ -5931,1118 +6697,7 @@
                           </a:solidFill>
                           <a:latin typeface="Arial"/>
                         </a:rPr>
-                        <a:t>Deprioritisieren (Prio 4)</a:t>
-                      </a:r>
-                    </a:p>
-                  </a:txBody>
-                  <a:tcPr/>
-                </a:tc>
-              </a:tr>
-            </a:tbl>
-          </a:graphicData>
-        </a:graphic>
-      </p:graphicFrame>
-      <p:sp>
-        <p:nvSpPr>
-          <p:cNvPr id="8" name="Rectangle 7"/>
-          <p:cNvSpPr/>
-          <p:nvPr/>
-        </p:nvSpPr>
-        <p:spPr>
-          <a:xfrm>
-            <a:off x="0" y="6510528"/>
-            <a:ext cx="12188952" cy="347472"/>
-          </a:xfrm>
-          <a:prstGeom prst="rect">
-            <a:avLst/>
-          </a:prstGeom>
-          <a:solidFill>
-            <a:srgbClr val="0A1937"/>
-          </a:solidFill>
-          <a:ln>
-            <a:noFill/>
-          </a:ln>
-        </p:spPr>
-        <p:style>
-          <a:lnRef idx="1">
-            <a:schemeClr val="accent1"/>
-          </a:lnRef>
-          <a:fillRef idx="3">
-            <a:schemeClr val="accent1"/>
-          </a:fillRef>
-          <a:effectRef idx="2">
-            <a:schemeClr val="accent1"/>
-          </a:effectRef>
-          <a:fontRef idx="minor">
-            <a:schemeClr val="lt1"/>
-          </a:fontRef>
-        </p:style>
-        <p:txBody>
-          <a:bodyPr rtlCol="0" anchor="ctr"/>
-          <a:lstStyle/>
-          <a:p>
-            <a:pPr algn="ctr"/>
-          </a:p>
-        </p:txBody>
-      </p:sp>
-      <p:sp>
-        <p:nvSpPr>
-          <p:cNvPr id="9" name="TextBox 8"/>
-          <p:cNvSpPr txBox="1"/>
-          <p:nvPr/>
-        </p:nvSpPr>
-        <p:spPr>
-          <a:xfrm>
-            <a:off x="685800" y="6583680"/>
-            <a:ext cx="6490411" cy="256032"/>
-          </a:xfrm>
-          <a:prstGeom prst="rect">
-            <a:avLst/>
-          </a:prstGeom>
-          <a:noFill/>
-        </p:spPr>
-        <p:txBody>
-          <a:bodyPr wrap="none">
-            <a:spAutoFit/>
-          </a:bodyPr>
-          <a:lstStyle/>
-          <a:p>
-            <a:pPr algn="l"/>
-            <a:r>
-              <a:rPr sz="700">
-                <a:solidFill>
-                  <a:srgbClr val="A0B4D2"/>
-                </a:solidFill>
-                <a:latin typeface="Consolas"/>
-              </a:rPr>
-              <a:t>FKB Campus  ·  M16</a:t>
-            </a:r>
-          </a:p>
-        </p:txBody>
-      </p:sp>
-      <p:sp>
-        <p:nvSpPr>
-          <p:cNvPr id="10" name="TextBox 9"/>
-          <p:cNvSpPr txBox="1"/>
-          <p:nvPr/>
-        </p:nvSpPr>
-        <p:spPr>
-          <a:xfrm>
-            <a:off x="7176211" y="6583680"/>
-            <a:ext cx="4326940" cy="256032"/>
-          </a:xfrm>
-          <a:prstGeom prst="rect">
-            <a:avLst/>
-          </a:prstGeom>
-          <a:noFill/>
-        </p:spPr>
-        <p:txBody>
-          <a:bodyPr wrap="none">
-            <a:spAutoFit/>
-          </a:bodyPr>
-          <a:lstStyle/>
-          <a:p>
-            <a:pPr algn="r"/>
-            <a:r>
-              <a:rPr sz="700">
-                <a:solidFill>
-                  <a:srgbClr val="A0B4D2"/>
-                </a:solidFill>
-                <a:latin typeface="Consolas"/>
-              </a:rPr>
-              <a:t>Übersicht</a:t>
-            </a:r>
-          </a:p>
-        </p:txBody>
-      </p:sp>
-    </p:spTree>
-  </p:cSld>
-  <p:clrMapOvr>
-    <a:masterClrMapping/>
-  </p:clrMapOvr>
-</p:sld>
-</file>
-
-<file path=ppt/slides/slide13.xml><?xml version="1.0" encoding="utf-8"?>
-<p:sld xmlns:a="http://schemas.openxmlformats.org/drawingml/2006/main" xmlns:p="http://schemas.openxmlformats.org/presentationml/2006/main" xmlns:r="http://schemas.openxmlformats.org/officeDocument/2006/relationships">
-  <p:cSld>
-    <p:spTree>
-      <p:nvGrpSpPr>
-        <p:cNvPr id="1" name=""/>
-        <p:cNvGrpSpPr/>
-        <p:nvPr/>
-      </p:nvGrpSpPr>
-      <p:grpSpPr/>
-      <p:sp>
-        <p:nvSpPr>
-          <p:cNvPr id="2" name="Rectangle 1"/>
-          <p:cNvSpPr/>
-          <p:nvPr/>
-        </p:nvSpPr>
-        <p:spPr>
-          <a:xfrm>
-            <a:off x="0" y="0"/>
-            <a:ext cx="12188952" cy="6858000"/>
-          </a:xfrm>
-          <a:prstGeom prst="rect">
-            <a:avLst/>
-          </a:prstGeom>
-          <a:solidFill>
-            <a:srgbClr val="EDEDF3"/>
-          </a:solidFill>
-          <a:ln>
-            <a:noFill/>
-          </a:ln>
-        </p:spPr>
-        <p:style>
-          <a:lnRef idx="1">
-            <a:schemeClr val="accent1"/>
-          </a:lnRef>
-          <a:fillRef idx="3">
-            <a:schemeClr val="accent1"/>
-          </a:fillRef>
-          <a:effectRef idx="2">
-            <a:schemeClr val="accent1"/>
-          </a:effectRef>
-          <a:fontRef idx="minor">
-            <a:schemeClr val="lt1"/>
-          </a:fontRef>
-        </p:style>
-        <p:txBody>
-          <a:bodyPr rtlCol="0" anchor="ctr"/>
-          <a:lstStyle/>
-          <a:p>
-            <a:pPr algn="ctr"/>
-          </a:p>
-        </p:txBody>
-      </p:sp>
-      <p:sp>
-        <p:nvSpPr>
-          <p:cNvPr id="3" name="Rectangle 2"/>
-          <p:cNvSpPr/>
-          <p:nvPr/>
-        </p:nvSpPr>
-        <p:spPr>
-          <a:xfrm>
-            <a:off x="0" y="0"/>
-            <a:ext cx="12188952" cy="50292"/>
-          </a:xfrm>
-          <a:prstGeom prst="rect">
-            <a:avLst/>
-          </a:prstGeom>
-          <a:solidFill>
-            <a:srgbClr val="1F2C56"/>
-          </a:solidFill>
-          <a:ln>
-            <a:noFill/>
-          </a:ln>
-        </p:spPr>
-        <p:style>
-          <a:lnRef idx="1">
-            <a:schemeClr val="accent1"/>
-          </a:lnRef>
-          <a:fillRef idx="3">
-            <a:schemeClr val="accent1"/>
-          </a:fillRef>
-          <a:effectRef idx="2">
-            <a:schemeClr val="accent1"/>
-          </a:effectRef>
-          <a:fontRef idx="minor">
-            <a:schemeClr val="lt1"/>
-          </a:fontRef>
-        </p:style>
-        <p:txBody>
-          <a:bodyPr rtlCol="0" anchor="ctr"/>
-          <a:lstStyle/>
-          <a:p>
-            <a:pPr algn="ctr"/>
-          </a:p>
-        </p:txBody>
-      </p:sp>
-      <p:sp>
-        <p:nvSpPr>
-          <p:cNvPr id="4" name="TextBox 3"/>
-          <p:cNvSpPr txBox="1"/>
-          <p:nvPr/>
-        </p:nvSpPr>
-        <p:spPr>
-          <a:xfrm>
-            <a:off x="685800" y="109728"/>
-            <a:ext cx="10817352" cy="228600"/>
-          </a:xfrm>
-          <a:prstGeom prst="rect">
-            <a:avLst/>
-          </a:prstGeom>
-          <a:noFill/>
-        </p:spPr>
-        <p:txBody>
-          <a:bodyPr wrap="none">
-            <a:spAutoFit/>
-          </a:bodyPr>
-          <a:lstStyle/>
-          <a:p>
-            <a:pPr algn="l"/>
-            <a:r>
-              <a:rPr sz="750">
-                <a:solidFill>
-                  <a:srgbClr val="78808C"/>
-                </a:solidFill>
-                <a:latin typeface="Consolas"/>
-              </a:rPr>
-              <a:t>M16  ·  INHALT</a:t>
-            </a:r>
-          </a:p>
-        </p:txBody>
-      </p:sp>
-      <p:sp>
-        <p:nvSpPr>
-          <p:cNvPr id="5" name="Rectangle 4"/>
-          <p:cNvSpPr/>
-          <p:nvPr/>
-        </p:nvSpPr>
-        <p:spPr>
-          <a:xfrm>
-            <a:off x="0" y="1234440"/>
-            <a:ext cx="12188952" cy="12700"/>
-          </a:xfrm>
-          <a:prstGeom prst="rect">
-            <a:avLst/>
-          </a:prstGeom>
-          <a:solidFill>
-            <a:srgbClr val="D8DFE4"/>
-          </a:solidFill>
-          <a:ln>
-            <a:noFill/>
-          </a:ln>
-        </p:spPr>
-        <p:style>
-          <a:lnRef idx="1">
-            <a:schemeClr val="accent1"/>
-          </a:lnRef>
-          <a:fillRef idx="3">
-            <a:schemeClr val="accent1"/>
-          </a:fillRef>
-          <a:effectRef idx="2">
-            <a:schemeClr val="accent1"/>
-          </a:effectRef>
-          <a:fontRef idx="minor">
-            <a:schemeClr val="lt1"/>
-          </a:fontRef>
-        </p:style>
-        <p:txBody>
-          <a:bodyPr rtlCol="0" anchor="ctr"/>
-          <a:lstStyle/>
-          <a:p>
-            <a:pPr algn="ctr"/>
-          </a:p>
-        </p:txBody>
-      </p:sp>
-      <p:sp>
-        <p:nvSpPr>
-          <p:cNvPr id="6" name="Rectangle 5"/>
-          <p:cNvSpPr/>
-          <p:nvPr/>
-        </p:nvSpPr>
-        <p:spPr>
-          <a:xfrm>
-            <a:off x="685800" y="502920"/>
-            <a:ext cx="36576" cy="658368"/>
-          </a:xfrm>
-          <a:prstGeom prst="rect">
-            <a:avLst/>
-          </a:prstGeom>
-          <a:solidFill>
-            <a:srgbClr val="D9C089"/>
-          </a:solidFill>
-          <a:ln>
-            <a:noFill/>
-          </a:ln>
-        </p:spPr>
-        <p:style>
-          <a:lnRef idx="1">
-            <a:schemeClr val="accent1"/>
-          </a:lnRef>
-          <a:fillRef idx="3">
-            <a:schemeClr val="accent1"/>
-          </a:fillRef>
-          <a:effectRef idx="2">
-            <a:schemeClr val="accent1"/>
-          </a:effectRef>
-          <a:fontRef idx="minor">
-            <a:schemeClr val="lt1"/>
-          </a:fontRef>
-        </p:style>
-        <p:txBody>
-          <a:bodyPr rtlCol="0" anchor="ctr"/>
-          <a:lstStyle/>
-          <a:p>
-            <a:pPr algn="ctr"/>
-          </a:p>
-        </p:txBody>
-      </p:sp>
-      <p:sp>
-        <p:nvSpPr>
-          <p:cNvPr id="7" name="TextBox 6"/>
-          <p:cNvSpPr txBox="1"/>
-          <p:nvPr/>
-        </p:nvSpPr>
-        <p:spPr>
-          <a:xfrm>
-            <a:off x="813816" y="502920"/>
-            <a:ext cx="10634472" cy="685800"/>
-          </a:xfrm>
-          <a:prstGeom prst="rect">
-            <a:avLst/>
-          </a:prstGeom>
-          <a:noFill/>
-        </p:spPr>
-        <p:txBody>
-          <a:bodyPr wrap="square">
-            <a:spAutoFit/>
-          </a:bodyPr>
-          <a:lstStyle/>
-          <a:p>
-            <a:pPr algn="l"/>
-            <a:r>
-              <a:rPr sz="2400" b="1" i="0">
-                <a:solidFill>
-                  <a:srgbClr val="1F2C56"/>
-                </a:solidFill>
-                <a:latin typeface="Arial"/>
-              </a:rPr>
-              <a:t>Schritt 3: Handeln und dokumentieren</a:t>
-            </a:r>
-          </a:p>
-        </p:txBody>
-      </p:sp>
-      <p:sp>
-        <p:nvSpPr>
-          <p:cNvPr id="8" name="TextBox 7"/>
-          <p:cNvSpPr txBox="1"/>
-          <p:nvPr/>
-        </p:nvSpPr>
-        <p:spPr>
-          <a:xfrm>
-            <a:off x="685800" y="1417320"/>
-            <a:ext cx="10817352" cy="4892040"/>
-          </a:xfrm>
-          <a:prstGeom prst="rect">
-            <a:avLst/>
-          </a:prstGeom>
-          <a:noFill/>
-        </p:spPr>
-        <p:txBody>
-          <a:bodyPr wrap="square">
-            <a:spAutoFit/>
-          </a:bodyPr>
-          <a:lstStyle/>
-          <a:p>
-            <a:pPr marL="190500" indent="-190500">
-              <a:spcBef>
-                <a:spcPts val="400"/>
-              </a:spcBef>
-              <a:spcAft>
-                <a:spcPts val="200"/>
-              </a:spcAft>
-            </a:pPr>
-            <a:r>
-              <a:rPr sz="1300">
-                <a:solidFill>
-                  <a:srgbClr val="3D5466"/>
-                </a:solidFill>
-                <a:latin typeface="Arial"/>
-              </a:rPr>
-              <a:t>▸  Für jeden Prio-1-Kunden: konkrete Maßnahme definieren, Termin setzen, in agree dokumentieren. Die Maßnahme muss einem der vier NMZ-Hebel zugeordnet sein:</a:t>
-            </a:r>
-          </a:p>
-          <a:p>
-            <a:pPr marL="190500" indent="-190500">
-              <a:spcBef>
-                <a:spcPts val="400"/>
-              </a:spcBef>
-              <a:spcAft>
-                <a:spcPts val="200"/>
-              </a:spcAft>
-            </a:pPr>
-            <a:r>
-              <a:rPr sz="1300">
-                <a:solidFill>
-                  <a:srgbClr val="3D5466"/>
-                </a:solidFill>
-                <a:latin typeface="Arial"/>
-              </a:rPr>
-              <a:t>▸  Zinshebel: Konditionengespräch vorbereiten (→ M14)</a:t>
-            </a:r>
-          </a:p>
-          <a:p>
-            <a:pPr marL="190500" indent="-190500">
-              <a:spcBef>
-                <a:spcPts val="400"/>
-              </a:spcBef>
-              <a:spcAft>
-                <a:spcPts val="200"/>
-              </a:spcAft>
-            </a:pPr>
-            <a:r>
-              <a:rPr sz="1300">
-                <a:solidFill>
-                  <a:srgbClr val="3D5466"/>
-                </a:solidFill>
-                <a:latin typeface="Arial"/>
-              </a:rPr>
-              <a:t>▸  Verbundhebel: Verbundpartner-Termin vereinbaren (→ M13)</a:t>
-            </a:r>
-          </a:p>
-          <a:p>
-            <a:pPr marL="190500" indent="-190500">
-              <a:spcBef>
-                <a:spcPts val="400"/>
-              </a:spcBef>
-              <a:spcAft>
-                <a:spcPts val="200"/>
-              </a:spcAft>
-            </a:pPr>
-            <a:r>
-              <a:rPr sz="1300">
-                <a:solidFill>
-                  <a:srgbClr val="3D5466"/>
-                </a:solidFill>
-                <a:latin typeface="Arial"/>
-              </a:rPr>
-              <a:t>▸  Risikohebel: Rating-Gespräch, Besicherungsoptimierung (gemeinsam mit Marktfolge/Kredit)</a:t>
-            </a:r>
-          </a:p>
-          <a:p>
-            <a:pPr marL="190500" indent="-190500">
-              <a:spcBef>
-                <a:spcPts val="400"/>
-              </a:spcBef>
-              <a:spcAft>
-                <a:spcPts val="200"/>
-              </a:spcAft>
-            </a:pPr>
-            <a:r>
-              <a:rPr sz="1300">
-                <a:solidFill>
-                  <a:srgbClr val="3D5466"/>
-                </a:solidFill>
-                <a:latin typeface="Arial"/>
-              </a:rPr>
-              <a:t>▸  Kostenhebel: Betreuungsintensität überprüfen (Führungsgespräch)</a:t>
-            </a:r>
-          </a:p>
-          <a:p>
-            <a:pPr marL="177800" indent="-177800">
-              <a:spcBef>
-                <a:spcPts val="600"/>
-              </a:spcBef>
-              <a:spcAft>
-                <a:spcPts val="200"/>
-              </a:spcAft>
-            </a:pPr>
-            <a:r>
-              <a:rPr sz="1200" i="1">
-                <a:solidFill>
-                  <a:srgbClr val="3D5466"/>
-                </a:solidFill>
-                <a:latin typeface="Arial"/>
-              </a:rPr>
-              <a:t>→  Stichwort-Leitfaden: Margenverteidigung im Konditionsgespräch</a:t>
-            </a:r>
-          </a:p>
-          <a:p>
-            <a:pPr marL="177800" indent="-177800">
-              <a:spcBef>
-                <a:spcPts val="600"/>
-              </a:spcBef>
-              <a:spcAft>
-                <a:spcPts val="200"/>
-              </a:spcAft>
-            </a:pPr>
-            <a:r>
-              <a:rPr sz="1200" i="1">
-                <a:solidFill>
-                  <a:srgbClr val="3D5466"/>
-                </a:solidFill>
-                <a:latin typeface="Arial"/>
-              </a:rPr>
-              <a:t>→  Das Ablesen der NMZ ist der einfache Teil. Das Gespräch mit dem Kunden über eine Margenanpassung ist der schwierige. Drei praxiserprobte Argumentationslinien:</a:t>
-            </a:r>
-          </a:p>
-          <a:p>
-            <a:pPr marL="190500" indent="-190500">
-              <a:spcBef>
-                <a:spcPts val="400"/>
-              </a:spcBef>
-              <a:spcAft>
-                <a:spcPts val="200"/>
-              </a:spcAft>
-            </a:pPr>
-            <a:r>
-              <a:rPr sz="1300">
-                <a:solidFill>
-                  <a:srgbClr val="3D5466"/>
-                </a:solidFill>
-                <a:latin typeface="Arial"/>
-              </a:rPr>
-              <a:t>▸  ## 4.5 Praxiscase: Felix Braun optimiert seinen Bestand</a:t>
-            </a:r>
-          </a:p>
-          <a:p>
-            <a:pPr marL="190500" indent="-190500">
-              <a:spcBef>
-                <a:spcPts val="400"/>
-              </a:spcBef>
-              <a:spcAft>
-                <a:spcPts val="200"/>
-              </a:spcAft>
-            </a:pPr>
-            <a:r>
-              <a:rPr sz="1300">
-                <a:solidFill>
-                  <a:srgbClr val="3D5466"/>
-                </a:solidFill>
-                <a:latin typeface="Arial"/>
-              </a:rPr>
-              <a:t>▸  Ausgangssituation</a:t>
-            </a:r>
-          </a:p>
-          <a:p>
-            <a:pPr marL="190500" indent="-190500">
-              <a:spcBef>
-                <a:spcPts val="400"/>
-              </a:spcBef>
-              <a:spcAft>
-                <a:spcPts val="200"/>
-              </a:spcAft>
-            </a:pPr>
-            <a:r>
-              <a:rPr sz="1300">
-                <a:solidFill>
-                  <a:srgbClr val="3D5466"/>
-                </a:solidFill>
-                <a:latin typeface="Arial"/>
-              </a:rPr>
-              <a:t>▸  Analyse</a:t>
-            </a:r>
-          </a:p>
-          <a:p>
-            <a:pPr marL="190500" indent="-190500">
-              <a:spcBef>
-                <a:spcPts val="400"/>
-              </a:spcBef>
-              <a:spcAft>
-                <a:spcPts val="200"/>
-              </a:spcAft>
-            </a:pPr>
-            <a:r>
-              <a:rPr sz="1300">
-                <a:solidFill>
-                  <a:srgbClr val="3D5466"/>
-                </a:solidFill>
-                <a:latin typeface="Arial"/>
-              </a:rPr>
-              <a:t>▸  Felix ruft das Bestandsranking auf. Er sieht sofort: Sieben Kunden haben eine NMZ unter 0,5 %, davon zwei mit negativem DB. Die Hauptursache variiert:</a:t>
-            </a:r>
-          </a:p>
-          <a:p>
-            <a:pPr marL="190500" indent="-190500">
-              <a:spcBef>
-                <a:spcPts val="400"/>
-              </a:spcBef>
-              <a:spcAft>
-                <a:spcPts val="200"/>
-              </a:spcAft>
-            </a:pPr>
-            <a:r>
-              <a:rPr sz="1300">
-                <a:solidFill>
-                  <a:srgbClr val="3D5466"/>
-                </a:solidFill>
-                <a:latin typeface="Arial"/>
-              </a:rPr>
-              <a:t>▸  Felix priorisiert</a:t>
-            </a:r>
-          </a:p>
-        </p:txBody>
-      </p:sp>
-      <p:sp>
-        <p:nvSpPr>
-          <p:cNvPr id="9" name="Rectangle 8"/>
-          <p:cNvSpPr/>
-          <p:nvPr/>
-        </p:nvSpPr>
-        <p:spPr>
-          <a:xfrm>
-            <a:off x="0" y="6510528"/>
-            <a:ext cx="12188952" cy="347472"/>
-          </a:xfrm>
-          <a:prstGeom prst="rect">
-            <a:avLst/>
-          </a:prstGeom>
-          <a:solidFill>
-            <a:srgbClr val="0A1937"/>
-          </a:solidFill>
-          <a:ln>
-            <a:noFill/>
-          </a:ln>
-        </p:spPr>
-        <p:style>
-          <a:lnRef idx="1">
-            <a:schemeClr val="accent1"/>
-          </a:lnRef>
-          <a:fillRef idx="3">
-            <a:schemeClr val="accent1"/>
-          </a:fillRef>
-          <a:effectRef idx="2">
-            <a:schemeClr val="accent1"/>
-          </a:effectRef>
-          <a:fontRef idx="minor">
-            <a:schemeClr val="lt1"/>
-          </a:fontRef>
-        </p:style>
-        <p:txBody>
-          <a:bodyPr rtlCol="0" anchor="ctr"/>
-          <a:lstStyle/>
-          <a:p>
-            <a:pPr algn="ctr"/>
-          </a:p>
-        </p:txBody>
-      </p:sp>
-      <p:sp>
-        <p:nvSpPr>
-          <p:cNvPr id="10" name="TextBox 9"/>
-          <p:cNvSpPr txBox="1"/>
-          <p:nvPr/>
-        </p:nvSpPr>
-        <p:spPr>
-          <a:xfrm>
-            <a:off x="685800" y="6583680"/>
-            <a:ext cx="6490411" cy="256032"/>
-          </a:xfrm>
-          <a:prstGeom prst="rect">
-            <a:avLst/>
-          </a:prstGeom>
-          <a:noFill/>
-        </p:spPr>
-        <p:txBody>
-          <a:bodyPr wrap="none">
-            <a:spAutoFit/>
-          </a:bodyPr>
-          <a:lstStyle/>
-          <a:p>
-            <a:pPr algn="l"/>
-            <a:r>
-              <a:rPr sz="700">
-                <a:solidFill>
-                  <a:srgbClr val="A0B4D2"/>
-                </a:solidFill>
-                <a:latin typeface="Consolas"/>
-              </a:rPr>
-              <a:t>FKB Campus  ·  M16</a:t>
-            </a:r>
-          </a:p>
-        </p:txBody>
-      </p:sp>
-    </p:spTree>
-  </p:cSld>
-  <p:clrMapOvr>
-    <a:masterClrMapping/>
-  </p:clrMapOvr>
-</p:sld>
-</file>
-
-<file path=ppt/slides/slide14.xml><?xml version="1.0" encoding="utf-8"?>
-<p:sld xmlns:a="http://schemas.openxmlformats.org/drawingml/2006/main" xmlns:p="http://schemas.openxmlformats.org/presentationml/2006/main" xmlns:r="http://schemas.openxmlformats.org/officeDocument/2006/relationships">
-  <p:cSld>
-    <p:spTree>
-      <p:nvGrpSpPr>
-        <p:cNvPr id="1" name=""/>
-        <p:cNvGrpSpPr/>
-        <p:nvPr/>
-      </p:nvGrpSpPr>
-      <p:grpSpPr/>
-      <p:sp>
-        <p:nvSpPr>
-          <p:cNvPr id="2" name="Rectangle 1"/>
-          <p:cNvSpPr/>
-          <p:nvPr/>
-        </p:nvSpPr>
-        <p:spPr>
-          <a:xfrm>
-            <a:off x="0" y="0"/>
-            <a:ext cx="12188952" cy="6858000"/>
-          </a:xfrm>
-          <a:prstGeom prst="rect">
-            <a:avLst/>
-          </a:prstGeom>
-          <a:solidFill>
-            <a:srgbClr val="FFFFFF"/>
-          </a:solidFill>
-          <a:ln>
-            <a:noFill/>
-          </a:ln>
-        </p:spPr>
-        <p:style>
-          <a:lnRef idx="1">
-            <a:schemeClr val="accent1"/>
-          </a:lnRef>
-          <a:fillRef idx="3">
-            <a:schemeClr val="accent1"/>
-          </a:fillRef>
-          <a:effectRef idx="2">
-            <a:schemeClr val="accent1"/>
-          </a:effectRef>
-          <a:fontRef idx="minor">
-            <a:schemeClr val="lt1"/>
-          </a:fontRef>
-        </p:style>
-        <p:txBody>
-          <a:bodyPr rtlCol="0" anchor="ctr"/>
-          <a:lstStyle/>
-          <a:p>
-            <a:pPr algn="ctr"/>
-          </a:p>
-        </p:txBody>
-      </p:sp>
-      <p:sp>
-        <p:nvSpPr>
-          <p:cNvPr id="3" name="Rectangle 2"/>
-          <p:cNvSpPr/>
-          <p:nvPr/>
-        </p:nvSpPr>
-        <p:spPr>
-          <a:xfrm>
-            <a:off x="0" y="0"/>
-            <a:ext cx="12188952" cy="50292"/>
-          </a:xfrm>
-          <a:prstGeom prst="rect">
-            <a:avLst/>
-          </a:prstGeom>
-          <a:solidFill>
-            <a:srgbClr val="1F2C56"/>
-          </a:solidFill>
-          <a:ln>
-            <a:noFill/>
-          </a:ln>
-        </p:spPr>
-        <p:style>
-          <a:lnRef idx="1">
-            <a:schemeClr val="accent1"/>
-          </a:lnRef>
-          <a:fillRef idx="3">
-            <a:schemeClr val="accent1"/>
-          </a:fillRef>
-          <a:effectRef idx="2">
-            <a:schemeClr val="accent1"/>
-          </a:effectRef>
-          <a:fontRef idx="minor">
-            <a:schemeClr val="lt1"/>
-          </a:fontRef>
-        </p:style>
-        <p:txBody>
-          <a:bodyPr rtlCol="0" anchor="ctr"/>
-          <a:lstStyle/>
-          <a:p>
-            <a:pPr algn="ctr"/>
-          </a:p>
-        </p:txBody>
-      </p:sp>
-      <p:sp>
-        <p:nvSpPr>
-          <p:cNvPr id="4" name="TextBox 3"/>
-          <p:cNvSpPr txBox="1"/>
-          <p:nvPr/>
-        </p:nvSpPr>
-        <p:spPr>
-          <a:xfrm>
-            <a:off x="685800" y="109728"/>
-            <a:ext cx="10817352" cy="228600"/>
-          </a:xfrm>
-          <a:prstGeom prst="rect">
-            <a:avLst/>
-          </a:prstGeom>
-          <a:noFill/>
-        </p:spPr>
-        <p:txBody>
-          <a:bodyPr wrap="none">
-            <a:spAutoFit/>
-          </a:bodyPr>
-          <a:lstStyle/>
-          <a:p>
-            <a:pPr algn="l"/>
-            <a:r>
-              <a:rPr sz="750">
-                <a:solidFill>
-                  <a:srgbClr val="78808C"/>
-                </a:solidFill>
-                <a:latin typeface="Consolas"/>
-              </a:rPr>
-              <a:t>M16  ·  ÜBERSICHT</a:t>
-            </a:r>
-          </a:p>
-        </p:txBody>
-      </p:sp>
-      <p:sp>
-        <p:nvSpPr>
-          <p:cNvPr id="5" name="TextBox 4"/>
-          <p:cNvSpPr txBox="1"/>
-          <p:nvPr/>
-        </p:nvSpPr>
-        <p:spPr>
-          <a:xfrm>
-            <a:off x="685800" y="502920"/>
-            <a:ext cx="10817352" cy="594360"/>
-          </a:xfrm>
-          <a:prstGeom prst="rect">
-            <a:avLst/>
-          </a:prstGeom>
-          <a:noFill/>
-        </p:spPr>
-        <p:txBody>
-          <a:bodyPr wrap="square">
-            <a:spAutoFit/>
-          </a:bodyPr>
-          <a:lstStyle/>
-          <a:p>
-            <a:pPr algn="l"/>
-            <a:r>
-              <a:rPr sz="2000" b="1" i="0">
-                <a:solidFill>
-                  <a:srgbClr val="1F2C56"/>
-                </a:solidFill>
-                <a:latin typeface="Arial"/>
-              </a:rPr>
-              <a:t>Schritt 3: Handeln und dokumentieren</a:t>
-            </a:r>
-          </a:p>
-        </p:txBody>
-      </p:sp>
-      <p:sp>
-        <p:nvSpPr>
-          <p:cNvPr id="6" name="Rectangle 5"/>
-          <p:cNvSpPr/>
-          <p:nvPr/>
-        </p:nvSpPr>
-        <p:spPr>
-          <a:xfrm>
-            <a:off x="685800" y="1143000"/>
-            <a:ext cx="10817352" cy="25400"/>
-          </a:xfrm>
-          <a:prstGeom prst="rect">
-            <a:avLst/>
-          </a:prstGeom>
-          <a:solidFill>
-            <a:srgbClr val="D9C089"/>
-          </a:solidFill>
-          <a:ln>
-            <a:noFill/>
-          </a:ln>
-        </p:spPr>
-        <p:style>
-          <a:lnRef idx="1">
-            <a:schemeClr val="accent1"/>
-          </a:lnRef>
-          <a:fillRef idx="3">
-            <a:schemeClr val="accent1"/>
-          </a:fillRef>
-          <a:effectRef idx="2">
-            <a:schemeClr val="accent1"/>
-          </a:effectRef>
-          <a:fontRef idx="minor">
-            <a:schemeClr val="lt1"/>
-          </a:fontRef>
-        </p:style>
-        <p:txBody>
-          <a:bodyPr rtlCol="0" anchor="ctr"/>
-          <a:lstStyle/>
-          <a:p>
-            <a:pPr algn="ctr"/>
-          </a:p>
-        </p:txBody>
-      </p:sp>
-      <p:graphicFrame>
-        <p:nvGraphicFramePr>
-          <p:cNvPr id="7" name="Table 6"/>
-          <p:cNvGraphicFramePr>
-            <a:graphicFrameLocks noGrp="1"/>
-          </p:cNvGraphicFramePr>
-          <p:nvPr/>
-        </p:nvGraphicFramePr>
-        <p:xfrm>
-          <a:off x="685800" y="1417320"/>
-          <a:ext cx="10817352" cy="2304288"/>
-        </p:xfrm>
-        <a:graphic>
-          <a:graphicData uri="http://schemas.openxmlformats.org/drawingml/2006/table">
-            <a:tbl>
-              <a:tblPr firstRow="1" bandRow="1">
-                <a:tableStyleId>{5C22544A-7EE6-4342-B048-85BDC9FD1C3A}</a:tableStyleId>
-              </a:tblPr>
-              <a:tblGrid>
-                <a:gridCol w="2704338"/>
-                <a:gridCol w="2704338"/>
-                <a:gridCol w="2704338"/>
-                <a:gridCol w="2704338"/>
-              </a:tblGrid>
-              <a:tr h="384048">
-                <a:tc>
-                  <a:txBody>
-                    <a:bodyPr/>
-                    <a:lstStyle/>
-                    <a:p>
-                      <a:r>
-                        <a:rPr sz="1100" b="1">
-                          <a:solidFill>
-                            <a:srgbClr val="FFFFFF"/>
-                          </a:solidFill>
-                          <a:latin typeface="Arial"/>
-                        </a:rPr>
-                        <a:t>Kunde</a:t>
-                      </a:r>
-                    </a:p>
-                  </a:txBody>
-                  <a:tcPr>
-                    <a:solidFill>
-                      <a:srgbClr val="1F2C56"/>
-                    </a:solidFill>
-                  </a:tcPr>
-                </a:tc>
-                <a:tc>
-                  <a:txBody>
-                    <a:bodyPr/>
-                    <a:lstStyle/>
-                    <a:p>
-                      <a:r>
-                        <a:rPr sz="1100" b="1">
-                          <a:solidFill>
-                            <a:srgbClr val="FFFFFF"/>
-                          </a:solidFill>
-                          <a:latin typeface="Arial"/>
-                        </a:rPr>
-                        <a:t>NMZ</a:t>
-                      </a:r>
-                    </a:p>
-                  </a:txBody>
-                  <a:tcPr>
-                    <a:solidFill>
-                      <a:srgbClr val="1F2C56"/>
-                    </a:solidFill>
-                  </a:tcPr>
-                </a:tc>
-                <a:tc>
-                  <a:txBody>
-                    <a:bodyPr/>
-                    <a:lstStyle/>
-                    <a:p>
-                      <a:r>
-                        <a:rPr sz="1100" b="1">
-                          <a:solidFill>
-                            <a:srgbClr val="FFFFFF"/>
-                          </a:solidFill>
-                          <a:latin typeface="Arial"/>
-                        </a:rPr>
-                        <a:t>Hauptursache</a:t>
-                      </a:r>
-                    </a:p>
-                  </a:txBody>
-                  <a:tcPr>
-                    <a:solidFill>
-                      <a:srgbClr val="1F2C56"/>
-                    </a:solidFill>
-                  </a:tcPr>
-                </a:tc>
-                <a:tc>
-                  <a:txBody>
-                    <a:bodyPr/>
-                    <a:lstStyle/>
-                    <a:p>
-                      <a:r>
-                        <a:rPr sz="1100" b="1">
-                          <a:solidFill>
-                            <a:srgbClr val="FFFFFF"/>
-                          </a:solidFill>
-                          <a:latin typeface="Arial"/>
-                        </a:rPr>
-                        <a:t>Hebel</a:t>
-                      </a:r>
-                    </a:p>
-                  </a:txBody>
-                  <a:tcPr>
-                    <a:solidFill>
-                      <a:srgbClr val="1F2C56"/>
-                    </a:solidFill>
-                  </a:tcPr>
-                </a:tc>
-              </a:tr>
-              <a:tr h="384048">
-                <a:tc>
-                  <a:txBody>
-                    <a:bodyPr/>
-                    <a:lstStyle/>
-                    <a:p>
-                      <a:r>
-                        <a:rPr sz="1050">
-                          <a:solidFill>
-                            <a:srgbClr val="3D5466"/>
-                          </a:solidFill>
-                          <a:latin typeface="Arial"/>
-                        </a:rPr>
-                        <a:t>Metzger GmbH</a:t>
-                      </a:r>
-                    </a:p>
-                  </a:txBody>
-                  <a:tcPr/>
-                </a:tc>
-                <a:tc>
-                  <a:txBody>
-                    <a:bodyPr/>
-                    <a:lstStyle/>
-                    <a:p>
-                      <a:r>
-                        <a:rPr sz="1050">
-                          <a:solidFill>
-                            <a:srgbClr val="3D5466"/>
-                          </a:solidFill>
-                          <a:latin typeface="Arial"/>
-                        </a:rPr>
-                        <a:t>−0,20 %</a:t>
-                      </a:r>
-                    </a:p>
-                  </a:txBody>
-                  <a:tcPr/>
-                </a:tc>
-                <a:tc>
-                  <a:txBody>
-                    <a:bodyPr/>
-                    <a:lstStyle/>
-                    <a:p>
-                      <a:r>
-                        <a:rPr sz="1050">
-                          <a:solidFill>
-                            <a:srgbClr val="3D5466"/>
-                          </a:solidFill>
-                          <a:latin typeface="Arial"/>
-                        </a:rPr>
-                        <a:t>Rating D, Marge 1,10 %</a:t>
-                      </a:r>
-                    </a:p>
-                  </a:txBody>
-                  <a:tcPr/>
-                </a:tc>
-                <a:tc>
-                  <a:txBody>
-                    <a:bodyPr/>
-                    <a:lstStyle/>
-                    <a:p>
-                      <a:r>
-                        <a:rPr sz="1050">
-                          <a:solidFill>
-                            <a:srgbClr val="3D5466"/>
-                          </a:solidFill>
-                          <a:latin typeface="Arial"/>
-                        </a:rPr>
-                        <a:t>Rating / Exit</a:t>
+                        <a:t>—</a:t>
                       </a:r>
                     </a:p>
                   </a:txBody>
@@ -7062,7 +6717,7 @@
                           </a:solidFill>
                           <a:latin typeface="Arial"/>
                         </a:rPr>
-                        <a:t>Bau Franz KG</a:t>
+                        <a:t>NMZ &lt; 0,5 %</a:t>
                       </a:r>
                     </a:p>
                   </a:txBody>
@@ -7080,7 +6735,7 @@
                           </a:solidFill>
                           <a:latin typeface="Arial"/>
                         </a:rPr>
-                        <a:t>0,22 %</a:t>
+                        <a:t>7 Kunden</a:t>
                       </a:r>
                     </a:p>
                   </a:txBody>
@@ -7098,247 +6753,7 @@
                           </a:solidFill>
                           <a:latin typeface="Arial"/>
                         </a:rPr>
-                        <a:t>Niedrige Marge (0,95 %), kein Verbund</a:t>
-                      </a:r>
-                    </a:p>
-                  </a:txBody>
-                  <a:tcPr/>
-                </a:tc>
-                <a:tc>
-                  <a:txBody>
-                    <a:bodyPr/>
-                    <a:lstStyle/>
-                    <a:p>
-                      <a:r>
-                        <a:rPr sz="1050">
-                          <a:solidFill>
-                            <a:srgbClr val="3D5466"/>
-                          </a:solidFill>
-                          <a:latin typeface="Arial"/>
-                        </a:rPr>
-                        <a:t>Verbund + Zins</a:t>
-                      </a:r>
-                    </a:p>
-                  </a:txBody>
-                  <a:tcPr/>
-                </a:tc>
-              </a:tr>
-              <a:tr h="384048">
-                <a:tc>
-                  <a:txBody>
-                    <a:bodyPr/>
-                    <a:lstStyle/>
-                    <a:p>
-                      <a:r>
-                        <a:rPr sz="1050">
-                          <a:solidFill>
-                            <a:srgbClr val="3D5466"/>
-                          </a:solidFill>
-                          <a:latin typeface="Arial"/>
-                        </a:rPr>
-                        <a:t>Holz Meier</a:t>
-                      </a:r>
-                    </a:p>
-                  </a:txBody>
-                  <a:tcPr/>
-                </a:tc>
-                <a:tc>
-                  <a:txBody>
-                    <a:bodyPr/>
-                    <a:lstStyle/>
-                    <a:p>
-                      <a:r>
-                        <a:rPr sz="1050">
-                          <a:solidFill>
-                            <a:srgbClr val="3D5466"/>
-                          </a:solidFill>
-                          <a:latin typeface="Arial"/>
-                        </a:rPr>
-                        <a:t>0,38 %</a:t>
-                      </a:r>
-                    </a:p>
-                  </a:txBody>
-                  <a:tcPr/>
-                </a:tc>
-                <a:tc>
-                  <a:txBody>
-                    <a:bodyPr/>
-                    <a:lstStyle/>
-                    <a:p>
-                      <a:r>
-                        <a:rPr sz="1050">
-                          <a:solidFill>
-                            <a:srgbClr val="3D5466"/>
-                          </a:solidFill>
-                          <a:latin typeface="Arial"/>
-                        </a:rPr>
-                        <a:t>Hohe Betreuungskosten (22 Std.)</a:t>
-                      </a:r>
-                    </a:p>
-                  </a:txBody>
-                  <a:tcPr/>
-                </a:tc>
-                <a:tc>
-                  <a:txBody>
-                    <a:bodyPr/>
-                    <a:lstStyle/>
-                    <a:p>
-                      <a:r>
-                        <a:rPr sz="1050">
-                          <a:solidFill>
-                            <a:srgbClr val="3D5466"/>
-                          </a:solidFill>
-                          <a:latin typeface="Arial"/>
-                        </a:rPr>
-                        <a:t>Kostenhebel</a:t>
-                      </a:r>
-                    </a:p>
-                  </a:txBody>
-                  <a:tcPr/>
-                </a:tc>
-              </a:tr>
-              <a:tr h="384048">
-                <a:tc>
-                  <a:txBody>
-                    <a:bodyPr/>
-                    <a:lstStyle/>
-                    <a:p>
-                      <a:r>
-                        <a:rPr sz="1050">
-                          <a:solidFill>
-                            <a:srgbClr val="3D5466"/>
-                          </a:solidFill>
-                          <a:latin typeface="Arial"/>
-                        </a:rPr>
-                        <a:t>Auto König GmbH</a:t>
-                      </a:r>
-                    </a:p>
-                  </a:txBody>
-                  <a:tcPr/>
-                </a:tc>
-                <a:tc>
-                  <a:txBody>
-                    <a:bodyPr/>
-                    <a:lstStyle/>
-                    <a:p>
-                      <a:r>
-                        <a:rPr sz="1050">
-                          <a:solidFill>
-                            <a:srgbClr val="3D5466"/>
-                          </a:solidFill>
-                          <a:latin typeface="Arial"/>
-                        </a:rPr>
-                        <a:t>0,41 %</a:t>
-                      </a:r>
-                    </a:p>
-                  </a:txBody>
-                  <a:tcPr/>
-                </a:tc>
-                <a:tc>
-                  <a:txBody>
-                    <a:bodyPr/>
-                    <a:lstStyle/>
-                    <a:p>
-                      <a:r>
-                        <a:rPr sz="1050">
-                          <a:solidFill>
-                            <a:srgbClr val="3D5466"/>
-                          </a:solidFill>
-                          <a:latin typeface="Arial"/>
-                        </a:rPr>
-                        <a:t>Kein Verbund (R+V, UI beide offen)</a:t>
-                      </a:r>
-                    </a:p>
-                  </a:txBody>
-                  <a:tcPr/>
-                </a:tc>
-                <a:tc>
-                  <a:txBody>
-                    <a:bodyPr/>
-                    <a:lstStyle/>
-                    <a:p>
-                      <a:r>
-                        <a:rPr sz="1050">
-                          <a:solidFill>
-                            <a:srgbClr val="3D5466"/>
-                          </a:solidFill>
-                          <a:latin typeface="Arial"/>
-                        </a:rPr>
-                        <a:t>Verbund</a:t>
-                      </a:r>
-                    </a:p>
-                  </a:txBody>
-                  <a:tcPr/>
-                </a:tc>
-              </a:tr>
-              <a:tr h="384048">
-                <a:tc>
-                  <a:txBody>
-                    <a:bodyPr/>
-                    <a:lstStyle/>
-                    <a:p>
-                      <a:r>
-                        <a:rPr sz="1050">
-                          <a:solidFill>
-                            <a:srgbClr val="3D5466"/>
-                          </a:solidFill>
-                          <a:latin typeface="Arial"/>
-                        </a:rPr>
-                        <a:t>Druck Schmidt</a:t>
-                      </a:r>
-                    </a:p>
-                  </a:txBody>
-                  <a:tcPr/>
-                </a:tc>
-                <a:tc>
-                  <a:txBody>
-                    <a:bodyPr/>
-                    <a:lstStyle/>
-                    <a:p>
-                      <a:r>
-                        <a:rPr sz="1050">
-                          <a:solidFill>
-                            <a:srgbClr val="3D5466"/>
-                          </a:solidFill>
-                          <a:latin typeface="Arial"/>
-                        </a:rPr>
-                        <a:t>0,45 %</a:t>
-                      </a:r>
-                    </a:p>
-                  </a:txBody>
-                  <a:tcPr/>
-                </a:tc>
-                <a:tc>
-                  <a:txBody>
-                    <a:bodyPr/>
-                    <a:lstStyle/>
-                    <a:p>
-                      <a:r>
-                        <a:rPr sz="1050">
-                          <a:solidFill>
-                            <a:srgbClr val="3D5466"/>
-                          </a:solidFill>
-                          <a:latin typeface="Arial"/>
-                        </a:rPr>
-                        <a:t>Laufende Linie hoch ausgenutzt (EAD↑)</a:t>
-                      </a:r>
-                    </a:p>
-                  </a:txBody>
-                  <a:tcPr/>
-                </a:tc>
-                <a:tc>
-                  <a:txBody>
-                    <a:bodyPr/>
-                    <a:lstStyle/>
-                    <a:p>
-                      <a:r>
-                        <a:rPr sz="1050">
-                          <a:solidFill>
-                            <a:srgbClr val="3D5466"/>
-                          </a:solidFill>
-                          <a:latin typeface="Arial"/>
-                        </a:rPr>
-                        <a:t>Besicherung</a:t>
+                        <a:t>davon 2 negativer DB</a:t>
                       </a:r>
                     </a:p>
                   </a:txBody>
@@ -7596,7 +7011,7 @@
                 </a:solidFill>
                 <a:latin typeface="Consolas"/>
               </a:rPr>
-              <a:t>M16  ·  INHALT</a:t>
+              <a:t>M16  ·  ARBEITSBLATT</a:t>
             </a:r>
           </a:p>
         </p:txBody>
@@ -7717,7 +7132,7 @@
                 </a:solidFill>
                 <a:latin typeface="Arial"/>
               </a:rPr>
-              <a:t>AB-1: Mein NMZ-Bestandsbild</a:t>
+              <a:t>Praxisfall bearbeiten: NMZ-Bestandsbild und Maßnahmenplan</a:t>
             </a:r>
           </a:p>
         </p:txBody>
@@ -7730,8 +7145,8 @@
         </p:nvSpPr>
         <p:spPr>
           <a:xfrm>
-            <a:off x="685800" y="1417320"/>
-            <a:ext cx="10817352" cy="4892040"/>
+            <a:off x="685800" y="1554480"/>
+            <a:ext cx="10817352" cy="3840480"/>
           </a:xfrm>
           <a:prstGeom prst="rect">
             <a:avLst/>
@@ -7739,7 +7154,7 @@
           <a:noFill/>
         </p:spPr>
         <p:txBody>
-          <a:bodyPr wrap="square" anchor="ctr">
+          <a:bodyPr wrap="square">
             <a:spAutoFit/>
           </a:bodyPr>
           <a:lstStyle/>
@@ -7753,13 +7168,13 @@
               </a:spcAft>
             </a:pPr>
             <a:r>
-              <a:rPr sz="1300">
+              <a:rPr sz="1400">
                 <a:solidFill>
                   <a:srgbClr val="3D5466"/>
                 </a:solidFill>
                 <a:latin typeface="Arial"/>
               </a:rPr>
-              <a:t>▸  Dominantes Schwachfeld in meinem Bestand:</a:t>
+              <a:t>▸  Erstellen Sie Ihr NMZ-Bestandsbild und markieren Sie die Kunden unter Benchmark (AB-1).</a:t>
             </a:r>
           </a:p>
           <a:p>
@@ -7772,13 +7187,32 @@
               </a:spcAft>
             </a:pPr>
             <a:r>
-              <a:rPr sz="1300">
+              <a:rPr sz="1400">
                 <a:solidFill>
                   <a:srgbClr val="3D5466"/>
                 </a:solidFill>
                 <a:latin typeface="Arial"/>
               </a:rPr>
-              <a:t>▸  ☐ Zinsmarge zu niedrig  ☐ Verbundgeschäft fehlt  ☐ Risikokosten zu hoch  ☐ Betreuungskosten zu hoch</a:t>
+              <a:t>▸  Priorisieren Sie die drei Kunden mit dem größten Hebel.</a:t>
+            </a:r>
+          </a:p>
+          <a:p>
+            <a:pPr marL="190500" indent="-190500">
+              <a:spcBef>
+                <a:spcPts val="400"/>
+              </a:spcBef>
+              <a:spcAft>
+                <a:spcPts val="200"/>
+              </a:spcAft>
+            </a:pPr>
+            <a:r>
+              <a:rPr sz="1400">
+                <a:solidFill>
+                  <a:srgbClr val="3D5466"/>
+                </a:solidFill>
+                <a:latin typeface="Arial"/>
+              </a:rPr>
+              <a:t>▸  Entwickeln Sie je Kunde einen Maßnahmenplan mit Ursache, Hebel und Termin (AB-2).</a:t>
             </a:r>
           </a:p>
         </p:txBody>
@@ -7786,6 +7220,84 @@
       <p:sp>
         <p:nvSpPr>
           <p:cNvPr id="9" name="Rectangle 8"/>
+          <p:cNvSpPr/>
+          <p:nvPr/>
+        </p:nvSpPr>
+        <p:spPr>
+          <a:xfrm>
+            <a:off x="685800" y="5486400"/>
+            <a:ext cx="10817352" cy="640080"/>
+          </a:xfrm>
+          <a:prstGeom prst="rect">
+            <a:avLst/>
+          </a:prstGeom>
+          <a:solidFill>
+            <a:srgbClr val="1F2C56"/>
+          </a:solidFill>
+          <a:ln>
+            <a:noFill/>
+          </a:ln>
+        </p:spPr>
+        <p:style>
+          <a:lnRef idx="1">
+            <a:schemeClr val="accent1"/>
+          </a:lnRef>
+          <a:fillRef idx="3">
+            <a:schemeClr val="accent1"/>
+          </a:fillRef>
+          <a:effectRef idx="2">
+            <a:schemeClr val="accent1"/>
+          </a:effectRef>
+          <a:fontRef idx="minor">
+            <a:schemeClr val="lt1"/>
+          </a:fontRef>
+        </p:style>
+        <p:txBody>
+          <a:bodyPr rtlCol="0" anchor="ctr"/>
+          <a:lstStyle/>
+          <a:p>
+            <a:pPr algn="ctr"/>
+          </a:p>
+        </p:txBody>
+      </p:sp>
+      <p:sp>
+        <p:nvSpPr>
+          <p:cNvPr id="10" name="TextBox 9"/>
+          <p:cNvSpPr txBox="1"/>
+          <p:nvPr/>
+        </p:nvSpPr>
+        <p:spPr>
+          <a:xfrm>
+            <a:off x="868680" y="5596128"/>
+            <a:ext cx="10451592" cy="457200"/>
+          </a:xfrm>
+          <a:prstGeom prst="rect">
+            <a:avLst/>
+          </a:prstGeom>
+          <a:noFill/>
+        </p:spPr>
+        <p:txBody>
+          <a:bodyPr wrap="square">
+            <a:spAutoFit/>
+          </a:bodyPr>
+          <a:lstStyle/>
+          <a:p>
+            <a:pPr algn="l"/>
+            <a:r>
+              <a:rPr sz="1300" b="1" i="0">
+                <a:solidFill>
+                  <a:srgbClr val="FFFFFF"/>
+                </a:solidFill>
+                <a:latin typeface="Arial"/>
+              </a:rPr>
+              <a:t>→  Bearbeitung im Teilnehmer-Workbook (Arbeitsblatt mit Ausfüllfeldern)</a:t>
+            </a:r>
+          </a:p>
+        </p:txBody>
+      </p:sp>
+      <p:sp>
+        <p:nvSpPr>
+          <p:cNvPr id="11" name="Rectangle 10"/>
           <p:cNvSpPr/>
           <p:nvPr/>
         </p:nvSpPr>
@@ -7828,7 +7340,7 @@
       </p:sp>
       <p:sp>
         <p:nvSpPr>
-          <p:cNvPr id="10" name="TextBox 9"/>
+          <p:cNvPr id="12" name="TextBox 11"/>
           <p:cNvSpPr txBox="1"/>
           <p:nvPr/>
         </p:nvSpPr>
@@ -7894,7 +7406,7 @@
             <a:avLst/>
           </a:prstGeom>
           <a:solidFill>
-            <a:srgbClr val="FFFFFF"/>
+            <a:srgbClr val="EDEDF3"/>
           </a:solidFill>
           <a:ln>
             <a:noFill/>
@@ -7995,43 +7507,51 @@
                 </a:solidFill>
                 <a:latin typeface="Consolas"/>
               </a:rPr>
-              <a:t>M16  ·  ÜBERSICHT</a:t>
-            </a:r>
-          </a:p>
-        </p:txBody>
-      </p:sp>
-      <p:sp>
-        <p:nvSpPr>
-          <p:cNvPr id="5" name="TextBox 4"/>
-          <p:cNvSpPr txBox="1"/>
-          <p:nvPr/>
-        </p:nvSpPr>
-        <p:spPr>
-          <a:xfrm>
-            <a:off x="685800" y="502920"/>
-            <a:ext cx="10817352" cy="594360"/>
-          </a:xfrm>
-          <a:prstGeom prst="rect">
-            <a:avLst/>
-          </a:prstGeom>
-          <a:noFill/>
-        </p:spPr>
-        <p:txBody>
-          <a:bodyPr wrap="square">
-            <a:spAutoFit/>
-          </a:bodyPr>
-          <a:lstStyle/>
-          <a:p>
-            <a:pPr algn="l"/>
-            <a:r>
-              <a:rPr sz="2000" b="1" i="0">
-                <a:solidFill>
-                  <a:srgbClr val="1F2C56"/>
-                </a:solidFill>
-                <a:latin typeface="Arial"/>
-              </a:rPr>
-              <a:t>AB-1: Mein NMZ-Bestandsbild</a:t>
-            </a:r>
+              <a:t>M16  ·  INHALT</a:t>
+            </a:r>
+          </a:p>
+        </p:txBody>
+      </p:sp>
+      <p:sp>
+        <p:nvSpPr>
+          <p:cNvPr id="5" name="Rectangle 4"/>
+          <p:cNvSpPr/>
+          <p:nvPr/>
+        </p:nvSpPr>
+        <p:spPr>
+          <a:xfrm>
+            <a:off x="0" y="1234440"/>
+            <a:ext cx="12188952" cy="12700"/>
+          </a:xfrm>
+          <a:prstGeom prst="rect">
+            <a:avLst/>
+          </a:prstGeom>
+          <a:solidFill>
+            <a:srgbClr val="D8DFE4"/>
+          </a:solidFill>
+          <a:ln>
+            <a:noFill/>
+          </a:ln>
+        </p:spPr>
+        <p:style>
+          <a:lnRef idx="1">
+            <a:schemeClr val="accent1"/>
+          </a:lnRef>
+          <a:fillRef idx="3">
+            <a:schemeClr val="accent1"/>
+          </a:fillRef>
+          <a:effectRef idx="2">
+            <a:schemeClr val="accent1"/>
+          </a:effectRef>
+          <a:fontRef idx="minor">
+            <a:schemeClr val="lt1"/>
+          </a:fontRef>
+        </p:style>
+        <p:txBody>
+          <a:bodyPr rtlCol="0" anchor="ctr"/>
+          <a:lstStyle/>
+          <a:p>
+            <a:pPr algn="ctr"/>
           </a:p>
         </p:txBody>
       </p:sp>
@@ -8043,8 +7563,8 @@
         </p:nvSpPr>
         <p:spPr>
           <a:xfrm>
-            <a:off x="685800" y="1143000"/>
-            <a:ext cx="10817352" cy="25400"/>
+            <a:off x="685800" y="502920"/>
+            <a:ext cx="36576" cy="658368"/>
           </a:xfrm>
           <a:prstGeom prst="rect">
             <a:avLst/>
@@ -8078,410 +7598,105 @@
           </a:p>
         </p:txBody>
       </p:sp>
-      <p:graphicFrame>
-        <p:nvGraphicFramePr>
-          <p:cNvPr id="7" name="Table 6"/>
-          <p:cNvGraphicFramePr>
-            <a:graphicFrameLocks noGrp="1"/>
-          </p:cNvGraphicFramePr>
-          <p:nvPr/>
-        </p:nvGraphicFramePr>
-        <p:xfrm>
-          <a:off x="685800" y="1417320"/>
-          <a:ext cx="10817352" cy="2304288"/>
-        </p:xfrm>
-        <a:graphic>
-          <a:graphicData uri="http://schemas.openxmlformats.org/drawingml/2006/table">
-            <a:tbl>
-              <a:tblPr firstRow="1" bandRow="1">
-                <a:tableStyleId>{5C22544A-7EE6-4342-B048-85BDC9FD1C3A}</a:tableStyleId>
-              </a:tblPr>
-              <a:tblGrid>
-                <a:gridCol w="2163470"/>
-                <a:gridCol w="2163470"/>
-                <a:gridCol w="2163470"/>
-                <a:gridCol w="2163470"/>
-                <a:gridCol w="2163472"/>
-              </a:tblGrid>
-              <a:tr h="384048">
-                <a:tc>
-                  <a:txBody>
-                    <a:bodyPr/>
-                    <a:lstStyle/>
-                    <a:p>
-                      <a:r>
-                        <a:rPr sz="1100" b="1">
-                          <a:solidFill>
-                            <a:srgbClr val="FFFFFF"/>
-                          </a:solidFill>
-                          <a:latin typeface="Arial"/>
-                        </a:rPr>
-                        <a:t>Rang (von unten)</a:t>
-                      </a:r>
-                    </a:p>
-                  </a:txBody>
-                  <a:tcPr>
-                    <a:solidFill>
-                      <a:srgbClr val="1F2C56"/>
-                    </a:solidFill>
-                  </a:tcPr>
-                </a:tc>
-                <a:tc>
-                  <a:txBody>
-                    <a:bodyPr/>
-                    <a:lstStyle/>
-                    <a:p>
-                      <a:r>
-                        <a:rPr sz="1100" b="1">
-                          <a:solidFill>
-                            <a:srgbClr val="FFFFFF"/>
-                          </a:solidFill>
-                          <a:latin typeface="Arial"/>
-                        </a:rPr>
-                        <a:t>Kunde (anonymisiert)</a:t>
-                      </a:r>
-                    </a:p>
-                  </a:txBody>
-                  <a:tcPr>
-                    <a:solidFill>
-                      <a:srgbClr val="1F2C56"/>
-                    </a:solidFill>
-                  </a:tcPr>
-                </a:tc>
-                <a:tc>
-                  <a:txBody>
-                    <a:bodyPr/>
-                    <a:lstStyle/>
-                    <a:p>
-                      <a:r>
-                        <a:rPr sz="1100" b="1">
-                          <a:solidFill>
-                            <a:srgbClr val="FFFFFF"/>
-                          </a:solidFill>
-                          <a:latin typeface="Arial"/>
-                        </a:rPr>
-                        <a:t>NMZ</a:t>
-                      </a:r>
-                    </a:p>
-                  </a:txBody>
-                  <a:tcPr>
-                    <a:solidFill>
-                      <a:srgbClr val="1F2C56"/>
-                    </a:solidFill>
-                  </a:tcPr>
-                </a:tc>
-                <a:tc>
-                  <a:txBody>
-                    <a:bodyPr/>
-                    <a:lstStyle/>
-                    <a:p>
-                      <a:r>
-                        <a:rPr sz="1100" b="1">
-                          <a:solidFill>
-                            <a:srgbClr val="FFFFFF"/>
-                          </a:solidFill>
-                          <a:latin typeface="Arial"/>
-                        </a:rPr>
-                        <a:t>Hauptursache</a:t>
-                      </a:r>
-                    </a:p>
-                  </a:txBody>
-                  <a:tcPr>
-                    <a:solidFill>
-                      <a:srgbClr val="1F2C56"/>
-                    </a:solidFill>
-                  </a:tcPr>
-                </a:tc>
-                <a:tc>
-                  <a:txBody>
-                    <a:bodyPr/>
-                    <a:lstStyle/>
-                    <a:p>
-                      <a:r>
-                        <a:rPr sz="1100" b="1">
-                          <a:solidFill>
-                            <a:srgbClr val="FFFFFF"/>
-                          </a:solidFill>
-                          <a:latin typeface="Arial"/>
-                        </a:rPr>
-                        <a:t>Hebel</a:t>
-                      </a:r>
-                    </a:p>
-                  </a:txBody>
-                  <a:tcPr>
-                    <a:solidFill>
-                      <a:srgbClr val="1F2C56"/>
-                    </a:solidFill>
-                  </a:tcPr>
-                </a:tc>
-              </a:tr>
-              <a:tr h="384048">
-                <a:tc>
-                  <a:txBody>
-                    <a:bodyPr/>
-                    <a:lstStyle/>
-                    <a:p>
-                      <a:r>
-                        <a:rPr sz="1050">
-                          <a:solidFill>
-                            <a:srgbClr val="3D5466"/>
-                          </a:solidFill>
-                          <a:latin typeface="Arial"/>
-                        </a:rPr>
-                        <a:t>1</a:t>
-                      </a:r>
-                    </a:p>
-                  </a:txBody>
-                  <a:tcPr/>
-                </a:tc>
-                <a:tc>
-                  <a:txBody>
-                    <a:bodyPr/>
-                    <a:lstStyle/>
-                    <a:p/>
-                  </a:txBody>
-                  <a:tcPr/>
-                </a:tc>
-                <a:tc>
-                  <a:txBody>
-                    <a:bodyPr/>
-                    <a:lstStyle/>
-                    <a:p/>
-                  </a:txBody>
-                  <a:tcPr/>
-                </a:tc>
-                <a:tc>
-                  <a:txBody>
-                    <a:bodyPr/>
-                    <a:lstStyle/>
-                    <a:p/>
-                  </a:txBody>
-                  <a:tcPr/>
-                </a:tc>
-                <a:tc>
-                  <a:txBody>
-                    <a:bodyPr/>
-                    <a:lstStyle/>
-                    <a:p/>
-                  </a:txBody>
-                  <a:tcPr/>
-                </a:tc>
-              </a:tr>
-              <a:tr h="384048">
-                <a:tc>
-                  <a:txBody>
-                    <a:bodyPr/>
-                    <a:lstStyle/>
-                    <a:p>
-                      <a:r>
-                        <a:rPr sz="1050">
-                          <a:solidFill>
-                            <a:srgbClr val="3D5466"/>
-                          </a:solidFill>
-                          <a:latin typeface="Arial"/>
-                        </a:rPr>
-                        <a:t>2</a:t>
-                      </a:r>
-                    </a:p>
-                  </a:txBody>
-                  <a:tcPr/>
-                </a:tc>
-                <a:tc>
-                  <a:txBody>
-                    <a:bodyPr/>
-                    <a:lstStyle/>
-                    <a:p/>
-                  </a:txBody>
-                  <a:tcPr/>
-                </a:tc>
-                <a:tc>
-                  <a:txBody>
-                    <a:bodyPr/>
-                    <a:lstStyle/>
-                    <a:p/>
-                  </a:txBody>
-                  <a:tcPr/>
-                </a:tc>
-                <a:tc>
-                  <a:txBody>
-                    <a:bodyPr/>
-                    <a:lstStyle/>
-                    <a:p/>
-                  </a:txBody>
-                  <a:tcPr/>
-                </a:tc>
-                <a:tc>
-                  <a:txBody>
-                    <a:bodyPr/>
-                    <a:lstStyle/>
-                    <a:p/>
-                  </a:txBody>
-                  <a:tcPr/>
-                </a:tc>
-              </a:tr>
-              <a:tr h="384048">
-                <a:tc>
-                  <a:txBody>
-                    <a:bodyPr/>
-                    <a:lstStyle/>
-                    <a:p>
-                      <a:r>
-                        <a:rPr sz="1050">
-                          <a:solidFill>
-                            <a:srgbClr val="3D5466"/>
-                          </a:solidFill>
-                          <a:latin typeface="Arial"/>
-                        </a:rPr>
-                        <a:t>3</a:t>
-                      </a:r>
-                    </a:p>
-                  </a:txBody>
-                  <a:tcPr/>
-                </a:tc>
-                <a:tc>
-                  <a:txBody>
-                    <a:bodyPr/>
-                    <a:lstStyle/>
-                    <a:p/>
-                  </a:txBody>
-                  <a:tcPr/>
-                </a:tc>
-                <a:tc>
-                  <a:txBody>
-                    <a:bodyPr/>
-                    <a:lstStyle/>
-                    <a:p/>
-                  </a:txBody>
-                  <a:tcPr/>
-                </a:tc>
-                <a:tc>
-                  <a:txBody>
-                    <a:bodyPr/>
-                    <a:lstStyle/>
-                    <a:p/>
-                  </a:txBody>
-                  <a:tcPr/>
-                </a:tc>
-                <a:tc>
-                  <a:txBody>
-                    <a:bodyPr/>
-                    <a:lstStyle/>
-                    <a:p/>
-                  </a:txBody>
-                  <a:tcPr/>
-                </a:tc>
-              </a:tr>
-              <a:tr h="384048">
-                <a:tc>
-                  <a:txBody>
-                    <a:bodyPr/>
-                    <a:lstStyle/>
-                    <a:p>
-                      <a:r>
-                        <a:rPr sz="1050">
-                          <a:solidFill>
-                            <a:srgbClr val="3D5466"/>
-                          </a:solidFill>
-                          <a:latin typeface="Arial"/>
-                        </a:rPr>
-                        <a:t>4</a:t>
-                      </a:r>
-                    </a:p>
-                  </a:txBody>
-                  <a:tcPr/>
-                </a:tc>
-                <a:tc>
-                  <a:txBody>
-                    <a:bodyPr/>
-                    <a:lstStyle/>
-                    <a:p/>
-                  </a:txBody>
-                  <a:tcPr/>
-                </a:tc>
-                <a:tc>
-                  <a:txBody>
-                    <a:bodyPr/>
-                    <a:lstStyle/>
-                    <a:p/>
-                  </a:txBody>
-                  <a:tcPr/>
-                </a:tc>
-                <a:tc>
-                  <a:txBody>
-                    <a:bodyPr/>
-                    <a:lstStyle/>
-                    <a:p/>
-                  </a:txBody>
-                  <a:tcPr/>
-                </a:tc>
-                <a:tc>
-                  <a:txBody>
-                    <a:bodyPr/>
-                    <a:lstStyle/>
-                    <a:p/>
-                  </a:txBody>
-                  <a:tcPr/>
-                </a:tc>
-              </a:tr>
-              <a:tr h="384048">
-                <a:tc>
-                  <a:txBody>
-                    <a:bodyPr/>
-                    <a:lstStyle/>
-                    <a:p>
-                      <a:r>
-                        <a:rPr sz="1050">
-                          <a:solidFill>
-                            <a:srgbClr val="3D5466"/>
-                          </a:solidFill>
-                          <a:latin typeface="Arial"/>
-                        </a:rPr>
-                        <a:t>5</a:t>
-                      </a:r>
-                    </a:p>
-                  </a:txBody>
-                  <a:tcPr/>
-                </a:tc>
-                <a:tc>
-                  <a:txBody>
-                    <a:bodyPr/>
-                    <a:lstStyle/>
-                    <a:p/>
-                  </a:txBody>
-                  <a:tcPr/>
-                </a:tc>
-                <a:tc>
-                  <a:txBody>
-                    <a:bodyPr/>
-                    <a:lstStyle/>
-                    <a:p/>
-                  </a:txBody>
-                  <a:tcPr/>
-                </a:tc>
-                <a:tc>
-                  <a:txBody>
-                    <a:bodyPr/>
-                    <a:lstStyle/>
-                    <a:p/>
-                  </a:txBody>
-                  <a:tcPr/>
-                </a:tc>
-                <a:tc>
-                  <a:txBody>
-                    <a:bodyPr/>
-                    <a:lstStyle/>
-                    <a:p/>
-                  </a:txBody>
-                  <a:tcPr/>
-                </a:tc>
-              </a:tr>
-            </a:tbl>
-          </a:graphicData>
-        </a:graphic>
-      </p:graphicFrame>
-      <p:sp>
-        <p:nvSpPr>
-          <p:cNvPr id="8" name="Rectangle 7"/>
+      <p:sp>
+        <p:nvSpPr>
+          <p:cNvPr id="7" name="TextBox 6"/>
+          <p:cNvSpPr txBox="1"/>
+          <p:nvPr/>
+        </p:nvSpPr>
+        <p:spPr>
+          <a:xfrm>
+            <a:off x="813816" y="502920"/>
+            <a:ext cx="10634472" cy="685800"/>
+          </a:xfrm>
+          <a:prstGeom prst="rect">
+            <a:avLst/>
+          </a:prstGeom>
+          <a:noFill/>
+        </p:spPr>
+        <p:txBody>
+          <a:bodyPr wrap="square">
+            <a:spAutoFit/>
+          </a:bodyPr>
+          <a:lstStyle/>
+          <a:p>
+            <a:pPr algn="l"/>
+            <a:r>
+              <a:rPr sz="2400" b="1" i="0">
+                <a:solidFill>
+                  <a:srgbClr val="1F2C56"/>
+                </a:solidFill>
+                <a:latin typeface="Arial"/>
+              </a:rPr>
+              <a:t>Prinzip dieses Moduls</a:t>
+            </a:r>
+          </a:p>
+        </p:txBody>
+      </p:sp>
+      <p:sp>
+        <p:nvSpPr>
+          <p:cNvPr id="8" name="TextBox 7"/>
+          <p:cNvSpPr txBox="1"/>
+          <p:nvPr/>
+        </p:nvSpPr>
+        <p:spPr>
+          <a:xfrm>
+            <a:off x="685800" y="1417320"/>
+            <a:ext cx="10817352" cy="4892040"/>
+          </a:xfrm>
+          <a:prstGeom prst="rect">
+            <a:avLst/>
+          </a:prstGeom>
+          <a:noFill/>
+        </p:spPr>
+        <p:txBody>
+          <a:bodyPr wrap="square" anchor="ctr">
+            <a:spAutoFit/>
+          </a:bodyPr>
+          <a:lstStyle/>
+          <a:p>
+            <a:pPr marL="177800" indent="-177800">
+              <a:spcBef>
+                <a:spcPts val="600"/>
+              </a:spcBef>
+              <a:spcAft>
+                <a:spcPts val="200"/>
+              </a:spcAft>
+            </a:pPr>
+            <a:r>
+              <a:rPr sz="1200" i="1">
+                <a:solidFill>
+                  <a:srgbClr val="3D5466"/>
+                </a:solidFill>
+                <a:latin typeface="Arial"/>
+              </a:rPr>
+              <a:t>→  Steuere den Bestand über die eine Kennzahl, die alles bündelt: die Nettomarge.</a:t>
+            </a:r>
+          </a:p>
+          <a:p>
+            <a:pPr marL="190500" indent="-190500">
+              <a:spcBef>
+                <a:spcPts val="400"/>
+              </a:spcBef>
+              <a:spcAft>
+                <a:spcPts val="200"/>
+              </a:spcAft>
+            </a:pPr>
+            <a:r>
+              <a:rPr sz="1300">
+                <a:solidFill>
+                  <a:srgbClr val="3D5466"/>
+                </a:solidFill>
+                <a:latin typeface="Arial"/>
+              </a:rPr>
+              <a:t>▸  Die NMZ zeigt, wo Ertrag verloren geht – die drei Kunden mit dem größten Hebel schlagen zwanzig Aktionen ohne Fokus.</a:t>
+            </a:r>
+          </a:p>
+        </p:txBody>
+      </p:sp>
+      <p:sp>
+        <p:nvSpPr>
+          <p:cNvPr id="9" name="Rectangle 8"/>
           <p:cNvSpPr/>
           <p:nvPr/>
         </p:nvSpPr>
@@ -8524,7 +7739,7 @@
       </p:sp>
       <p:sp>
         <p:nvSpPr>
-          <p:cNvPr id="9" name="TextBox 8"/>
+          <p:cNvPr id="10" name="TextBox 9"/>
           <p:cNvSpPr txBox="1"/>
           <p:nvPr/>
         </p:nvSpPr>
@@ -8553,41 +7768,6 @@
                 <a:latin typeface="Consolas"/>
               </a:rPr>
               <a:t>FKB Campus  ·  M16</a:t>
-            </a:r>
-          </a:p>
-        </p:txBody>
-      </p:sp>
-      <p:sp>
-        <p:nvSpPr>
-          <p:cNvPr id="10" name="TextBox 9"/>
-          <p:cNvSpPr txBox="1"/>
-          <p:nvPr/>
-        </p:nvSpPr>
-        <p:spPr>
-          <a:xfrm>
-            <a:off x="7176211" y="6583680"/>
-            <a:ext cx="4326940" cy="256032"/>
-          </a:xfrm>
-          <a:prstGeom prst="rect">
-            <a:avLst/>
-          </a:prstGeom>
-          <a:noFill/>
-        </p:spPr>
-        <p:txBody>
-          <a:bodyPr wrap="none">
-            <a:spAutoFit/>
-          </a:bodyPr>
-          <a:lstStyle/>
-          <a:p>
-            <a:pPr algn="r"/>
-            <a:r>
-              <a:rPr sz="700">
-                <a:solidFill>
-                  <a:srgbClr val="A0B4D2"/>
-                </a:solidFill>
-                <a:latin typeface="Consolas"/>
-              </a:rPr>
-              <a:t>Übersicht</a:t>
             </a:r>
           </a:p>
         </p:txBody>
@@ -8847,7 +8027,7 @@
                 </a:solidFill>
                 <a:latin typeface="Arial"/>
               </a:rPr>
-              <a:t>AB-2: Maßnahmenplan</a:t>
+              <a:t>Reflexion und Selbstcheck</a:t>
             </a:r>
           </a:p>
         </p:txBody>
@@ -8889,7 +8069,45 @@
                 </a:solidFill>
                 <a:latin typeface="Arial"/>
               </a:rPr>
-              <a:t>▸  Mein Ziel für die nächsten 90 Tage:</a:t>
+              <a:t>▸  Welche drei Kunden in Ihrem Bestand haben den größten NMZ-Hebel?</a:t>
+            </a:r>
+          </a:p>
+          <a:p>
+            <a:pPr marL="190500" indent="-190500">
+              <a:spcBef>
+                <a:spcPts val="400"/>
+              </a:spcBef>
+              <a:spcAft>
+                <a:spcPts val="200"/>
+              </a:spcAft>
+            </a:pPr>
+            <a:r>
+              <a:rPr sz="1300">
+                <a:solidFill>
+                  <a:srgbClr val="3D5466"/>
+                </a:solidFill>
+                <a:latin typeface="Arial"/>
+              </a:rPr>
+              <a:t>▸  Wann in Ihrem Monat ist die feste halbe Stunde für den NMZ-Blick?</a:t>
+            </a:r>
+          </a:p>
+          <a:p>
+            <a:pPr marL="190500" indent="-190500">
+              <a:spcBef>
+                <a:spcPts val="400"/>
+              </a:spcBef>
+              <a:spcAft>
+                <a:spcPts val="200"/>
+              </a:spcAft>
+            </a:pPr>
+            <a:r>
+              <a:rPr sz="1300">
+                <a:solidFill>
+                  <a:srgbClr val="3D5466"/>
+                </a:solidFill>
+                <a:latin typeface="Arial"/>
+              </a:rPr>
+              <a:t>▸  Bei welchem Verlustbringer ist der Hebel eine Konditionsanpassung – und bei welchem der Exit?</a:t>
             </a:r>
           </a:p>
         </p:txBody>
@@ -10685,7 +9903,7 @@
                 </a:solidFill>
                 <a:latin typeface="Arial"/>
               </a:rPr>
-              <a:t>Definition</a:t>
+              <a:t>Die eine Kennzahl, die alles bündelt</a:t>
             </a:r>
           </a:p>
         </p:txBody>
@@ -10711,6 +9929,25 @@
             <a:spAutoFit/>
           </a:bodyPr>
           <a:lstStyle/>
+          <a:p>
+            <a:pPr marL="177800" indent="-177800">
+              <a:spcBef>
+                <a:spcPts val="600"/>
+              </a:spcBef>
+              <a:spcAft>
+                <a:spcPts val="200"/>
+              </a:spcAft>
+            </a:pPr>
+            <a:r>
+              <a:rPr sz="1200" i="1">
+                <a:solidFill>
+                  <a:srgbClr val="3D5466"/>
+                </a:solidFill>
+                <a:latin typeface="Arial"/>
+              </a:rPr>
+              <a:t>→  Steuere den Bestand über die eine Kennzahl, die alles bündelt: die Nettomarge (NMZ).</a:t>
+            </a:r>
+          </a:p>
           <a:p>
             <a:pPr marL="190500" indent="-190500">
               <a:spcBef>
@@ -10727,7 +9964,7 @@
                 </a:solidFill>
                 <a:latin typeface="Arial"/>
               </a:rPr>
-              <a:t>▸  NMZ (%) = Deckungsbeitrag II × 100 / Kreditvolumen</a:t>
+              <a:t>▸  Die NMZ vereint Zinsergebnis, Provisionen, Risikokosten und Eigenkapitalkosten in einer Zahl.</a:t>
             </a:r>
           </a:p>
           <a:p>
@@ -10746,7 +9983,7 @@
                 </a:solidFill>
                 <a:latin typeface="Arial"/>
               </a:rPr>
-              <a:t>▸  Sie ist damit die auf das Volumen normierte Version des Kundendeckungsbeitrags (M14), was Vergleiche zwischen Kunden unterschiedlicher Größe erst möglich macht.</a:t>
+              <a:t>▸  Sie zeigt, was ein Kunde nach allen Kosten wirklich zum Ergebnis beiträgt.</a:t>
             </a:r>
           </a:p>
         </p:txBody>
@@ -11084,7 +10321,7 @@
                 </a:solidFill>
                 <a:latin typeface="Arial"/>
               </a:rPr>
-              <a:t>Warum die NMZ dem DB überlegen ist</a:t>
+              <a:t>Warum die NMZ dem Deckungsbeitrag überlegen ist</a:t>
             </a:r>
           </a:p>
         </p:txBody>
@@ -11110,6 +10347,25 @@
             <a:spAutoFit/>
           </a:bodyPr>
           <a:lstStyle/>
+          <a:p>
+            <a:pPr marL="177800" indent="-177800">
+              <a:spcBef>
+                <a:spcPts val="600"/>
+              </a:spcBef>
+              <a:spcAft>
+                <a:spcPts val="200"/>
+              </a:spcAft>
+            </a:pPr>
+            <a:r>
+              <a:rPr sz="1200" i="1">
+                <a:solidFill>
+                  <a:srgbClr val="3D5466"/>
+                </a:solidFill>
+                <a:latin typeface="Arial"/>
+              </a:rPr>
+              <a:t>→  Der DB zeigt den Ertrag, die NMZ zeigt den Ertrag nach Risiko und Kapitalbindung – erst das ist Steuerungsgröße.</a:t>
+            </a:r>
+          </a:p>
           <a:p>
             <a:pPr marL="190500" indent="-190500">
               <a:spcBef>
@@ -11126,7 +10382,7 @@
                 </a:solidFill>
                 <a:latin typeface="Arial"/>
               </a:rPr>
-              <a:t>▸  Rolfes (1999 ) betont, dass Banken ohne normierte Ertragskennzahlen systematisch Kapital in renditeschwache Engagements lenken, weil die absoluten Beträge groß aussehen.</a:t>
+              <a:t>▸  Der DB ignoriert Risikokosten und Eigenkapitalkosten; die NMZ rechnet sie ein.</a:t>
             </a:r>
           </a:p>
           <a:p>
@@ -11145,45 +10401,7 @@
                 </a:solidFill>
                 <a:latin typeface="Arial"/>
               </a:rPr>
-              <a:t>▸  ## 4.2 Die NMZ-Komponenten im Detail</a:t>
-            </a:r>
-          </a:p>
-          <a:p>
-            <a:pPr marL="190500" indent="-190500">
-              <a:spcBef>
-                <a:spcPts val="400"/>
-              </a:spcBef>
-              <a:spcAft>
-                <a:spcPts val="200"/>
-              </a:spcAft>
-            </a:pPr>
-            <a:r>
-              <a:rPr sz="1300">
-                <a:solidFill>
-                  <a:srgbClr val="3D5466"/>
-                </a:solidFill>
-                <a:latin typeface="Arial"/>
-              </a:rPr>
-              <a:t>▸  Die NMZ wird von vier Treibern bewegt – jeder Treiber entspricht einem Hebel für die Optimierung:</a:t>
-            </a:r>
-          </a:p>
-          <a:p>
-            <a:pPr marL="190500" indent="-190500">
-              <a:spcBef>
-                <a:spcPts val="400"/>
-              </a:spcBef>
-              <a:spcAft>
-                <a:spcPts val="200"/>
-              </a:spcAft>
-            </a:pPr>
-            <a:r>
-              <a:rPr sz="1300">
-                <a:solidFill>
-                  <a:srgbClr val="3D5466"/>
-                </a:solidFill>
-                <a:latin typeface="Arial"/>
-              </a:rPr>
-              <a:t>▸  ## 4.3 NMZ-Berichte in agree lesen</a:t>
+              <a:t>▸  Zwei Kunden mit gleichem DB können völlig unterschiedliche NMZ haben.</a:t>
             </a:r>
           </a:p>
         </p:txBody>
@@ -11435,7 +10653,7 @@
                 </a:solidFill>
                 <a:latin typeface="Arial"/>
               </a:rPr>
-              <a:t>Nettomargenbeitrag NMZ</a:t>
+              <a:t>Der Nettomargenbeitrag (NMZ) im Aufbau</a:t>
             </a:r>
           </a:p>
         </p:txBody>
@@ -11875,7 +11093,7 @@
                 </a:solidFill>
                 <a:latin typeface="Arial"/>
               </a:rPr>
-              <a:t>Wo finde ich meine NMZ-Daten?</a:t>
+              <a:t>Wo die NMZ-Daten herkommen</a:t>
             </a:r>
           </a:p>
         </p:txBody>
@@ -11901,6 +11119,25 @@
             <a:spAutoFit/>
           </a:bodyPr>
           <a:lstStyle/>
+          <a:p>
+            <a:pPr marL="177800" indent="-177800">
+              <a:spcBef>
+                <a:spcPts val="600"/>
+              </a:spcBef>
+              <a:spcAft>
+                <a:spcPts val="200"/>
+              </a:spcAft>
+            </a:pPr>
+            <a:r>
+              <a:rPr sz="1200" i="1">
+                <a:solidFill>
+                  <a:srgbClr val="3D5466"/>
+                </a:solidFill>
+                <a:latin typeface="Arial"/>
+              </a:rPr>
+              <a:t>→  Die NMZ liegt im agree-Reporting bereit – man muss das Ranking nur regelmäßig lesen.</a:t>
+            </a:r>
+          </a:p>
           <a:p>
             <a:pPr marL="190500" indent="-190500">
               <a:spcBef>
@@ -11917,7 +11154,26 @@
                 </a:solidFill>
                 <a:latin typeface="Arial"/>
               </a:rPr>
-              <a:t>▸  In agree (Atruvia) stehen NMZ-relevante Auswertungen über folgende Einstiegspunkte zur Verfügung:</a:t>
+              <a:t>▸  Das Bestandsranking zeigt jeden Kunden mit seiner NMZ und den Komponenten.</a:t>
+            </a:r>
+          </a:p>
+          <a:p>
+            <a:pPr marL="190500" indent="-190500">
+              <a:spcBef>
+                <a:spcPts val="400"/>
+              </a:spcBef>
+              <a:spcAft>
+                <a:spcPts val="200"/>
+              </a:spcAft>
+            </a:pPr>
+            <a:r>
+              <a:rPr sz="1300">
+                <a:solidFill>
+                  <a:srgbClr val="3D5466"/>
+                </a:solidFill>
+                <a:latin typeface="Arial"/>
+              </a:rPr>
+              <a:t>▸  Interner Benchmark der Bank als Zielmarke (z. B. 1,10 %).</a:t>
             </a:r>
           </a:p>
         </p:txBody>
@@ -12033,7 +11289,7 @@
             <a:avLst/>
           </a:prstGeom>
           <a:solidFill>
-            <a:srgbClr val="EDEDF3"/>
+            <a:srgbClr val="1F2C56"/>
           </a:solidFill>
           <a:ln>
             <a:noFill/>
@@ -12063,57 +11319,14 @@
       </p:sp>
       <p:sp>
         <p:nvSpPr>
-          <p:cNvPr id="3" name="Rectangle 2"/>
-          <p:cNvSpPr/>
-          <p:nvPr/>
-        </p:nvSpPr>
-        <p:spPr>
-          <a:xfrm>
-            <a:off x="0" y="0"/>
-            <a:ext cx="12188952" cy="50292"/>
-          </a:xfrm>
-          <a:prstGeom prst="rect">
-            <a:avLst/>
-          </a:prstGeom>
-          <a:solidFill>
-            <a:srgbClr val="1F2C56"/>
-          </a:solidFill>
-          <a:ln>
-            <a:noFill/>
-          </a:ln>
-        </p:spPr>
-        <p:style>
-          <a:lnRef idx="1">
-            <a:schemeClr val="accent1"/>
-          </a:lnRef>
-          <a:fillRef idx="3">
-            <a:schemeClr val="accent1"/>
-          </a:fillRef>
-          <a:effectRef idx="2">
-            <a:schemeClr val="accent1"/>
-          </a:effectRef>
-          <a:fontRef idx="minor">
-            <a:schemeClr val="lt1"/>
-          </a:fontRef>
-        </p:style>
-        <p:txBody>
-          <a:bodyPr rtlCol="0" anchor="ctr"/>
-          <a:lstStyle/>
-          <a:p>
-            <a:pPr algn="ctr"/>
-          </a:p>
-        </p:txBody>
-      </p:sp>
-      <p:sp>
-        <p:nvSpPr>
-          <p:cNvPr id="4" name="TextBox 3"/>
+          <p:cNvPr id="3" name="TextBox 2"/>
           <p:cNvSpPr txBox="1"/>
           <p:nvPr/>
         </p:nvSpPr>
         <p:spPr>
           <a:xfrm>
-            <a:off x="685800" y="109728"/>
-            <a:ext cx="10817352" cy="228600"/>
+            <a:off x="685800" y="2377440"/>
+            <a:ext cx="10817352" cy="365760"/>
           </a:xfrm>
           <a:prstGeom prst="rect">
             <a:avLst/>
@@ -12128,70 +11341,27 @@
           <a:p>
             <a:pPr algn="l"/>
             <a:r>
-              <a:rPr sz="750">
-                <a:solidFill>
-                  <a:srgbClr val="78808C"/>
+              <a:rPr sz="1200">
+                <a:solidFill>
+                  <a:srgbClr val="D9C089"/>
                 </a:solidFill>
                 <a:latin typeface="Consolas"/>
               </a:rPr>
-              <a:t>M16  ·  INHALT</a:t>
-            </a:r>
-          </a:p>
-        </p:txBody>
-      </p:sp>
-      <p:sp>
-        <p:nvSpPr>
-          <p:cNvPr id="5" name="Rectangle 4"/>
+              <a:t>3 SCHRITTE</a:t>
+            </a:r>
+          </a:p>
+        </p:txBody>
+      </p:sp>
+      <p:sp>
+        <p:nvSpPr>
+          <p:cNvPr id="4" name="Rectangle 3"/>
           <p:cNvSpPr/>
           <p:nvPr/>
         </p:nvSpPr>
         <p:spPr>
           <a:xfrm>
-            <a:off x="0" y="1234440"/>
-            <a:ext cx="12188952" cy="12700"/>
-          </a:xfrm>
-          <a:prstGeom prst="rect">
-            <a:avLst/>
-          </a:prstGeom>
-          <a:solidFill>
-            <a:srgbClr val="D8DFE4"/>
-          </a:solidFill>
-          <a:ln>
-            <a:noFill/>
-          </a:ln>
-        </p:spPr>
-        <p:style>
-          <a:lnRef idx="1">
-            <a:schemeClr val="accent1"/>
-          </a:lnRef>
-          <a:fillRef idx="3">
-            <a:schemeClr val="accent1"/>
-          </a:fillRef>
-          <a:effectRef idx="2">
-            <a:schemeClr val="accent1"/>
-          </a:effectRef>
-          <a:fontRef idx="minor">
-            <a:schemeClr val="lt1"/>
-          </a:fontRef>
-        </p:style>
-        <p:txBody>
-          <a:bodyPr rtlCol="0" anchor="ctr"/>
-          <a:lstStyle/>
-          <a:p>
-            <a:pPr algn="ctr"/>
-          </a:p>
-        </p:txBody>
-      </p:sp>
-      <p:sp>
-        <p:nvSpPr>
-          <p:cNvPr id="6" name="Rectangle 5"/>
-          <p:cNvSpPr/>
-          <p:nvPr/>
-        </p:nvSpPr>
-        <p:spPr>
-          <a:xfrm>
-            <a:off x="685800" y="502920"/>
-            <a:ext cx="36576" cy="658368"/>
+            <a:off x="685800" y="2788920"/>
+            <a:ext cx="548640" cy="38100"/>
           </a:xfrm>
           <a:prstGeom prst="rect">
             <a:avLst/>
@@ -12227,14 +11397,14 @@
       </p:sp>
       <p:sp>
         <p:nvSpPr>
-          <p:cNvPr id="7" name="TextBox 6"/>
+          <p:cNvPr id="5" name="TextBox 4"/>
           <p:cNvSpPr txBox="1"/>
           <p:nvPr/>
         </p:nvSpPr>
         <p:spPr>
           <a:xfrm>
-            <a:off x="813816" y="502920"/>
-            <a:ext cx="10634472" cy="685800"/>
+            <a:off x="685800" y="3017520"/>
+            <a:ext cx="10817352" cy="1463040"/>
           </a:xfrm>
           <a:prstGeom prst="rect">
             <a:avLst/>
@@ -12249,27 +11419,27 @@
           <a:p>
             <a:pPr algn="l"/>
             <a:r>
-              <a:rPr sz="2400" b="1" i="0">
-                <a:solidFill>
-                  <a:srgbClr val="1F2C56"/>
+              <a:rPr sz="4000" b="1" i="0">
+                <a:solidFill>
+                  <a:srgbClr val="FFFFFF"/>
                 </a:solidFill>
                 <a:latin typeface="Arial"/>
               </a:rPr>
-              <a:t>Leseübung: NMZ-Ranking interpretieren</a:t>
-            </a:r>
-          </a:p>
-        </p:txBody>
-      </p:sp>
-      <p:sp>
-        <p:nvSpPr>
-          <p:cNvPr id="8" name="TextBox 7"/>
+              <a:t>Der NMZ-Optimierungsprozess</a:t>
+            </a:r>
+          </a:p>
+        </p:txBody>
+      </p:sp>
+      <p:sp>
+        <p:nvSpPr>
+          <p:cNvPr id="6" name="TextBox 5"/>
           <p:cNvSpPr txBox="1"/>
           <p:nvPr/>
         </p:nvSpPr>
         <p:spPr>
           <a:xfrm>
-            <a:off x="685800" y="1417320"/>
-            <a:ext cx="10817352" cy="4892040"/>
+            <a:off x="685800" y="4480560"/>
+            <a:ext cx="8653881" cy="1280160"/>
           </a:xfrm>
           <a:prstGeom prst="rect">
             <a:avLst/>
@@ -12277,160 +11447,34 @@
           <a:noFill/>
         </p:spPr>
         <p:txBody>
-          <a:bodyPr wrap="square" anchor="ctr">
+          <a:bodyPr wrap="square">
             <a:spAutoFit/>
           </a:bodyPr>
           <a:lstStyle/>
           <a:p>
-            <a:pPr marL="190500" indent="-190500">
-              <a:spcBef>
-                <a:spcPts val="400"/>
-              </a:spcBef>
-              <a:spcAft>
-                <a:spcPts val="200"/>
-              </a:spcAft>
-            </a:pPr>
-            <a:r>
-              <a:rPr sz="1300">
-                <a:solidFill>
-                  <a:srgbClr val="3D5466"/>
+            <a:pPr algn="l"/>
+            <a:r>
+              <a:rPr sz="1600" b="0" i="0">
+                <a:solidFill>
+                  <a:srgbClr val="C8D2E6"/>
                 </a:solidFill>
                 <a:latin typeface="Arial"/>
               </a:rPr>
-              <a:t>▸  Stellen Sie sich vor, Ihr Bestand zeigt folgendes NMZ-Ranking (Auszug):</a:t>
-            </a:r>
-          </a:p>
-          <a:p>
-            <a:pPr marL="190500" indent="-190500">
-              <a:spcBef>
-                <a:spcPts val="400"/>
-              </a:spcBef>
-              <a:spcAft>
-                <a:spcPts val="200"/>
-              </a:spcAft>
-            </a:pPr>
-            <a:r>
-              <a:rPr sz="1300">
-                <a:solidFill>
-                  <a:srgbClr val="3D5466"/>
-                </a:solidFill>
-                <a:latin typeface="Arial"/>
-              </a:rPr>
-              <a:t>▸  Sofortmaßnahmen aus diesem Ranking:</a:t>
-            </a:r>
-          </a:p>
-          <a:p>
-            <a:pPr marL="190500" indent="-190500">
-              <a:spcBef>
-                <a:spcPts val="400"/>
-              </a:spcBef>
-              <a:spcAft>
-                <a:spcPts val="200"/>
-              </a:spcAft>
-            </a:pPr>
-            <a:r>
-              <a:rPr sz="1300">
-                <a:solidFill>
-                  <a:srgbClr val="3D5466"/>
-                </a:solidFill>
-                <a:latin typeface="Arial"/>
-              </a:rPr>
-              <a:t>▸  Huber Bau GmbH (0,30 %): Rating prüfen, Besicherung optimieren, Verbund aktivieren</a:t>
-            </a:r>
-          </a:p>
-          <a:p>
-            <a:pPr marL="190500" indent="-190500">
-              <a:spcBef>
-                <a:spcPts val="400"/>
-              </a:spcBef>
-              <a:spcAft>
-                <a:spcPts val="200"/>
-              </a:spcAft>
-            </a:pPr>
-            <a:r>
-              <a:rPr sz="1300">
-                <a:solidFill>
-                  <a:srgbClr val="3D5466"/>
-                </a:solidFill>
-                <a:latin typeface="Arial"/>
-              </a:rPr>
-              <a:t>▸  Fischer Transport (−0,30 %): Konditionengespräch unverzüglich, Exit-Prüfung falls keine Verbesserung möglich</a:t>
-            </a:r>
-          </a:p>
-          <a:p>
-            <a:pPr marL="190500" indent="-190500">
-              <a:spcBef>
-                <a:spcPts val="400"/>
-              </a:spcBef>
-              <a:spcAft>
-                <a:spcPts val="200"/>
-              </a:spcAft>
-            </a:pPr>
-            <a:r>
-              <a:rPr sz="1300">
-                <a:solidFill>
-                  <a:srgbClr val="3D5466"/>
-                </a:solidFill>
-                <a:latin typeface="Arial"/>
-              </a:rPr>
-              <a:t>▸  ## 4.4 Der NMZ-Optimierungsprozess: 3 Schritte</a:t>
-            </a:r>
-          </a:p>
-        </p:txBody>
-      </p:sp>
-      <p:sp>
-        <p:nvSpPr>
-          <p:cNvPr id="9" name="Rectangle 8"/>
-          <p:cNvSpPr/>
-          <p:nvPr/>
-        </p:nvSpPr>
-        <p:spPr>
-          <a:xfrm>
-            <a:off x="0" y="6510528"/>
-            <a:ext cx="12188952" cy="347472"/>
-          </a:xfrm>
-          <a:prstGeom prst="rect">
-            <a:avLst/>
-          </a:prstGeom>
-          <a:solidFill>
-            <a:srgbClr val="0A1937"/>
-          </a:solidFill>
-          <a:ln>
-            <a:noFill/>
-          </a:ln>
-        </p:spPr>
-        <p:style>
-          <a:lnRef idx="1">
-            <a:schemeClr val="accent1"/>
-          </a:lnRef>
-          <a:fillRef idx="3">
-            <a:schemeClr val="accent1"/>
-          </a:fillRef>
-          <a:effectRef idx="2">
-            <a:schemeClr val="accent1"/>
-          </a:effectRef>
-          <a:fontRef idx="minor">
-            <a:schemeClr val="lt1"/>
-          </a:fontRef>
-        </p:style>
-        <p:txBody>
-          <a:bodyPr rtlCol="0" anchor="ctr"/>
-          <a:lstStyle/>
-          <a:p>
-            <a:pPr algn="ctr"/>
-          </a:p>
-        </p:txBody>
-      </p:sp>
-      <p:sp>
-        <p:nvSpPr>
-          <p:cNvPr id="10" name="TextBox 9"/>
+              <a:t>Identifizieren, priorisieren, handeln – monatlich, mit Fokus.</a:t>
+            </a:r>
+          </a:p>
+        </p:txBody>
+      </p:sp>
+      <p:sp>
+        <p:nvSpPr>
+          <p:cNvPr id="7" name="TextBox 6"/>
           <p:cNvSpPr txBox="1"/>
           <p:nvPr/>
         </p:nvSpPr>
         <p:spPr>
           <a:xfrm>
-            <a:off x="685800" y="6583680"/>
-            <a:ext cx="6490411" cy="256032"/>
+            <a:off x="685800" y="6355080"/>
+            <a:ext cx="10817352" cy="274320"/>
           </a:xfrm>
           <a:prstGeom prst="rect">
             <a:avLst/>
@@ -12447,7 +11491,7 @@
             <a:r>
               <a:rPr sz="700">
                 <a:solidFill>
-                  <a:srgbClr val="A0B4D2"/>
+                  <a:srgbClr val="8CA0C3"/>
                 </a:solidFill>
                 <a:latin typeface="Consolas"/>
               </a:rPr>

</xml_diff>

<commit_message>
M16: NMZ -> Kundennettomarge (KNM) - content + Artefakte + Grafik
- content/modules/M16.md gesynct (Titel, kurzbeschreibung, KNM durchgaengig)
- Grafik M16-nmz.svg (KNM-Labels), GRAFIKEN_MAP-Label aktualisiert
- Workbook-PDF, Deck, Trainerhandbuch, Beobachtungsbogen, Teamleiter-Leitfaden neu

Co-Authored-By: Claude Opus 4.8 <noreply@anthropic.com>
</commit_message>
<xml_diff>
--- a/protected-downloads/praesentation/M16.pptx
+++ b/protected-downloads/praesentation/M16.pptx
@@ -728,7 +728,7 @@
           <a:lstStyle/>
           <a:p>
             <a:r>
-              <a:t>Einstieg: „Welche Kennzahl nutzen Sie heute, um Ihren Bestand zu steuern?" Meist DB – die NMZ geht weiter.</a:t>
+              <a:t>Einstieg: „Welche Kennzahl nutzen Sie heute, um Ihren Bestand zu steuern?" Meist DB – die KNM geht weiter.</a:t>
             </a:r>
           </a:p>
         </p:txBody>
@@ -798,7 +798,7 @@
           <a:lstStyle/>
           <a:p>
             <a:r>
-              <a:t>Kernbotschaft: der DB kann trügen – ein margenstarker, aber risikoreicher Kunde ist auf NMZ-Basis oft unattraktiv.</a:t>
+              <a:t>Kernbotschaft: der DB kann trügen – ein margenstarker, aber risikoreicher Kunde ist auf KNM-Basis oft unattraktiv.</a:t>
             </a:r>
           </a:p>
         </p:txBody>
@@ -868,7 +868,7 @@
           <a:lstStyle/>
           <a:p>
             <a:r>
-              <a:t>Leseübung: ein NMZ-Ranking gemeinsam interpretieren – wo sitzt der Ertrag, wo die Verlustbringer?</a:t>
+              <a:t>Leseübung: ein KNM-Ranking gemeinsam interpretieren – wo sitzt der Ertrag, wo die Verlustbringer?</a:t>
             </a:r>
           </a:p>
         </p:txBody>
@@ -1148,7 +1148,7 @@
           <a:lstStyle/>
           <a:p>
             <a:r>
-              <a:t>Felix ist 0,29 Prozentpunkte unter Ziel. Sieben Kunden ziehen die Bestands-NMZ nach unten – dort liegt der Hebel.</a:t>
+              <a:t>Felix ist 0,29 Prozentpunkte unter Ziel. Sieben Kunden ziehen die Bestands-KNM nach unten – dort liegt der Hebel.</a:t>
             </a:r>
           </a:p>
         </p:txBody>
@@ -1223,7 +1223,7 @@
           </a:p>
           <a:p>
             <a:r>
-              <a:t>Beispiel Metzger GmbH: NMZ −0,20 %, Rating D, Marge zu niedrig – Hebel Rating/Exit, nicht Konditionen. Ursachengerecht handeln, nicht pauschal.</a:t>
+              <a:t>Beispiel Metzger GmbH: KNM −0,20 %, Rating D, Marge zu niedrig – Hebel Rating/Exit, nicht Konditionen. Ursachengerecht handeln, nicht pauschal.</a:t>
             </a:r>
           </a:p>
         </p:txBody>
@@ -4380,7 +4380,7 @@
                 </a:solidFill>
                 <a:latin typeface="Arial"/>
               </a:rPr>
-              <a:t>NMZ-Optimierung</a:t>
+              <a:t>Kundennettomarge optimieren</a:t>
             </a:r>
           </a:p>
         </p:txBody>
@@ -4415,7 +4415,7 @@
                 </a:solidFill>
                 <a:latin typeface="Arial"/>
               </a:rPr>
-              <a:t>Nettomargenziffer im Firmenkundenbestand messen, verstehen und systematisch verbessern</a:t>
+              <a:t>Kundennettomarge (KNM) im Firmenkundenbestand messen, verstehen und systematisch verbessern</a:t>
             </a:r>
           </a:p>
         </p:txBody>
@@ -5102,7 +5102,7 @@
                 </a:solidFill>
                 <a:latin typeface="Arial"/>
               </a:rPr>
-              <a:t>▸  Monatlich das NMZ-Ranking aufrufen und die Kunden unter Benchmark markieren.</a:t>
+              <a:t>▸  Monatlich das KNM-Ranking aufrufen und die Kunden unter Benchmark markieren.</a:t>
             </a:r>
           </a:p>
           <a:p>
@@ -5121,7 +5121,7 @@
                 </a:solidFill>
                 <a:latin typeface="Arial"/>
               </a:rPr>
-              <a:t>▸  Besonderes Augenmerk auf Kunden mit NMZ unter 0,5 % oder negativem DB.</a:t>
+              <a:t>▸  Besonderes Augenmerk auf Kunden mit KNM unter 0,5 % oder negativem DB.</a:t>
             </a:r>
           </a:p>
         </p:txBody>
@@ -5539,7 +5539,7 @@
                 </a:solidFill>
                 <a:latin typeface="Arial"/>
               </a:rPr>
-              <a:t>▸  Nach Hebelgröße sortieren – wo bringt eine Maßnahme den meisten NMZ-Zuwachs?</a:t>
+              <a:t>▸  Nach Hebelgröße sortieren – wo bringt eine Maßnahme den meisten KNM-Zuwachs?</a:t>
             </a:r>
           </a:p>
         </p:txBody>
@@ -5919,7 +5919,7 @@
                 </a:solidFill>
                 <a:latin typeface="Arial"/>
               </a:rPr>
-              <a:t>→  Eine erkannte NMZ-Lücke ist erst geschlossen, wenn die Maßnahme umgesetzt und dokumentiert ist.</a:t>
+              <a:t>→  Eine erkannte KNM-Lücke ist erst geschlossen, wenn die Maßnahme umgesetzt und dokumentiert ist.</a:t>
             </a:r>
           </a:p>
           <a:p>
@@ -6244,7 +6244,7 @@
                 </a:solidFill>
                 <a:latin typeface="Arial"/>
               </a:rPr>
-              <a:t>Ein Maßnahmenpaket entwickeln, das die Bestands-NMZ zum Benchmark bringt.</a:t>
+              <a:t>Ein Maßnahmenpaket entwickeln, das die Bestands-KNM zum Benchmark bringt.</a:t>
             </a:r>
           </a:p>
         </p:txBody>
@@ -6605,7 +6605,7 @@
                           </a:solidFill>
                           <a:latin typeface="Arial"/>
                         </a:rPr>
-                        <a:t>Bestands-NMZ</a:t>
+                        <a:t>Bestands-KNM</a:t>
                       </a:r>
                     </a:p>
                   </a:txBody>
@@ -6717,7 +6717,7 @@
                           </a:solidFill>
                           <a:latin typeface="Arial"/>
                         </a:rPr>
-                        <a:t>NMZ &lt; 0,5 %</a:t>
+                        <a:t>KNM &lt; 0,5 %</a:t>
                       </a:r>
                     </a:p>
                   </a:txBody>
@@ -7132,7 +7132,7 @@
                 </a:solidFill>
                 <a:latin typeface="Arial"/>
               </a:rPr>
-              <a:t>Praxisfall bearbeiten: NMZ-Bestandsbild und Maßnahmenplan</a:t>
+              <a:t>Praxisfall bearbeiten: KNM-Bestandsbild und Maßnahmenplan</a:t>
             </a:r>
           </a:p>
         </p:txBody>
@@ -7174,7 +7174,7 @@
                 </a:solidFill>
                 <a:latin typeface="Arial"/>
               </a:rPr>
-              <a:t>▸  Erstellen Sie Ihr NMZ-Bestandsbild und markieren Sie die Kunden unter Benchmark (AB-1).</a:t>
+              <a:t>▸  Erstellen Sie Ihr KNM-Bestandsbild und markieren Sie die Kunden unter Benchmark (AB-1).</a:t>
             </a:r>
           </a:p>
           <a:p>
@@ -7689,7 +7689,7 @@
                 </a:solidFill>
                 <a:latin typeface="Arial"/>
               </a:rPr>
-              <a:t>▸  Die NMZ zeigt, wo Ertrag verloren geht – die drei Kunden mit dem größten Hebel schlagen zwanzig Aktionen ohne Fokus.</a:t>
+              <a:t>▸  Die KNM zeigt, wo Ertrag verloren geht – die drei Kunden mit dem größten Hebel schlagen zwanzig Aktionen ohne Fokus.</a:t>
             </a:r>
           </a:p>
         </p:txBody>
@@ -8069,7 +8069,7 @@
                 </a:solidFill>
                 <a:latin typeface="Arial"/>
               </a:rPr>
-              <a:t>▸  Welche drei Kunden in Ihrem Bestand haben den größten NMZ-Hebel?</a:t>
+              <a:t>▸  Welche drei Kunden in Ihrem Bestand haben den größten KNM-Hebel?</a:t>
             </a:r>
           </a:p>
           <a:p>
@@ -8088,7 +8088,7 @@
                 </a:solidFill>
                 <a:latin typeface="Arial"/>
               </a:rPr>
-              <a:t>▸  Wann in Ihrem Monat ist die feste halbe Stunde für den NMZ-Blick?</a:t>
+              <a:t>▸  Wann in Ihrem Monat ist die feste halbe Stunde für den KNM-Blick?</a:t>
             </a:r>
           </a:p>
           <a:p>
@@ -8441,7 +8441,7 @@
                 </a:solidFill>
                 <a:latin typeface="Arial"/>
               </a:rPr>
-              <a:t>Ein erheblicher Teil der Beraterzeit fließt in Administration statt in Kundenkontakt.</a:t>
+              <a:t>Nicht jeder Kunde mit hohem Volumen bringt hohen Ertrag.</a:t>
             </a:r>
           </a:p>
           <a:p>
@@ -8457,7 +8457,7 @@
                 </a:solidFill>
                 <a:latin typeface="Arial"/>
               </a:rPr>
-              <a:t>Sie analysieren Ihre eigene Nettomarktzeit, identifizieren die größten Zeitfresser und entwickeln konkrete Gegenmaßnahmen.</a:t>
+              <a:t>Die Kundennettomarge (KNM) macht sichtbar, welchen bereinigten Nettoertrag ein Engagement je Euro Kreditvolumen wirklich abwirft – nach Refinanzierungs- und Risikokosten.</a:t>
             </a:r>
           </a:p>
           <a:p>
@@ -8473,7 +8473,23 @@
                 </a:solidFill>
                 <a:latin typeface="Arial"/>
               </a:rPr>
-              <a:t>Danach gewinnen Sie messbar Zeit für das, was Ertrag bringt: das Kundengespräch.</a:t>
+              <a:t>In diesem Modul lesen Sie Ihre KNM-Berichte in agree, identifizieren die Kunden mit dem größten Verbesserungspotenzial und leiten für jeden einen konkreten Ertragshebel ab.</a:t>
+            </a:r>
+          </a:p>
+          <a:p>
+            <a:pPr>
+              <a:spcAft>
+                <a:spcPts val="1200"/>
+              </a:spcAft>
+            </a:pPr>
+            <a:r>
+              <a:rPr sz="1700">
+                <a:solidFill>
+                  <a:srgbClr val="3D5466"/>
+                </a:solidFill>
+                <a:latin typeface="Arial"/>
+              </a:rPr>
+              <a:t>So steuern Sie Ihren Bestand nicht nach Volumen, sondern nach Ertrag.</a:t>
             </a:r>
           </a:p>
         </p:txBody>
@@ -8810,7 +8826,7 @@
                 </a:solidFill>
                 <a:latin typeface="Arial"/>
               </a:rPr>
-              <a:t>▸  Erklären, was die Nettomargenziffer (NMZ) misst, wie sie berechnet wird und warum sie die zentrale Steuerungsgröße im VR-Firmenkundensegment ist</a:t>
+              <a:t>▸  Erklären, was die Kundennettomarge (KNM) misst, wie sie berechnet wird und warum sie die zentrale Steuerungsgröße im VR-Firmenkundensegment ist</a:t>
             </a:r>
           </a:p>
           <a:p>
@@ -8829,7 +8845,7 @@
                 </a:solidFill>
                 <a:latin typeface="Arial"/>
               </a:rPr>
-              <a:t>▸  Unterschiede zwischen NMZ auf Einzel-, Segment- und Bestandsebene erläutern und die eigene NMZ in den internen Benchmark einordnen</a:t>
+              <a:t>▸  Unterschiede zwischen KNM auf Einzel-, Segment- und Bestandsebene erläutern und die eigene KNM in den internen Benchmark einordnen</a:t>
             </a:r>
           </a:p>
           <a:p>
@@ -8848,7 +8864,7 @@
                 </a:solidFill>
                 <a:latin typeface="Arial"/>
               </a:rPr>
-              <a:t>▸  NMZ-Berichte in agree lesen und die drei Kunden mit dem größten Verbesserungspotenzial im eigenen Bestand identifizieren</a:t>
+              <a:t>▸  KNM-Berichte in agree lesen und die drei Kunden mit dem größten Verbesserungspotenzial im eigenen Bestand identifizieren</a:t>
             </a:r>
           </a:p>
           <a:p>
@@ -8867,7 +8883,7 @@
                 </a:solidFill>
                 <a:latin typeface="Arial"/>
               </a:rPr>
-              <a:t>▸  Für jeden identifizierten Kunden mind. eine konkrete NMZ-Verbesserungsmaßnahme ableiten und den Hebel begründen</a:t>
+              <a:t>▸  Für jeden identifizierten Kunden mind. eine konkrete KNM-Verbesserungsmaßnahme ableiten und den Hebel begründen</a:t>
             </a:r>
           </a:p>
           <a:p>
@@ -8886,7 +8902,7 @@
                 </a:solidFill>
                 <a:latin typeface="Arial"/>
               </a:rPr>
-              <a:t>▸  Die NMZ-Struktur des Gesamtbestands nach Ertragskomponenten analysieren und das dominante Schwachfeld benennen</a:t>
+              <a:t>▸  Die KNM-Struktur des Gesamtbestands nach Ertragskomponenten analysieren und das dominante Schwachfeld benennen</a:t>
             </a:r>
           </a:p>
         </p:txBody>
@@ -9945,7 +9961,7 @@
                 </a:solidFill>
                 <a:latin typeface="Arial"/>
               </a:rPr>
-              <a:t>→  Steuere den Bestand über die eine Kennzahl, die alles bündelt: die Nettomarge (NMZ).</a:t>
+              <a:t>→  Steuere den Bestand über die eine Kennzahl, die alles bündelt: die Nettomarge (KNM).</a:t>
             </a:r>
           </a:p>
           <a:p>
@@ -9964,7 +9980,7 @@
                 </a:solidFill>
                 <a:latin typeface="Arial"/>
               </a:rPr>
-              <a:t>▸  Die NMZ vereint Zinsergebnis, Provisionen, Risikokosten und Eigenkapitalkosten in einer Zahl.</a:t>
+              <a:t>▸  Die KNM vereint Zinsergebnis, Provisionen, Risikokosten und Eigenkapitalkosten in einer Zahl.</a:t>
             </a:r>
           </a:p>
           <a:p>
@@ -10321,7 +10337,7 @@
                 </a:solidFill>
                 <a:latin typeface="Arial"/>
               </a:rPr>
-              <a:t>Warum die NMZ dem Deckungsbeitrag überlegen ist</a:t>
+              <a:t>Warum die KNM dem Deckungsbeitrag überlegen ist</a:t>
             </a:r>
           </a:p>
         </p:txBody>
@@ -10363,7 +10379,7 @@
                 </a:solidFill>
                 <a:latin typeface="Arial"/>
               </a:rPr>
-              <a:t>→  Der DB zeigt den Ertrag, die NMZ zeigt den Ertrag nach Risiko und Kapitalbindung – erst das ist Steuerungsgröße.</a:t>
+              <a:t>→  Der DB zeigt den Ertrag, die KNM zeigt den Ertrag nach Risiko und Kapitalbindung – erst das ist Steuerungsgröße.</a:t>
             </a:r>
           </a:p>
           <a:p>
@@ -10382,7 +10398,7 @@
                 </a:solidFill>
                 <a:latin typeface="Arial"/>
               </a:rPr>
-              <a:t>▸  Der DB ignoriert Risikokosten und Eigenkapitalkosten; die NMZ rechnet sie ein.</a:t>
+              <a:t>▸  Der DB ignoriert Risikokosten und Eigenkapitalkosten; die KNM rechnet sie ein.</a:t>
             </a:r>
           </a:p>
           <a:p>
@@ -10401,7 +10417,7 @@
                 </a:solidFill>
                 <a:latin typeface="Arial"/>
               </a:rPr>
-              <a:t>▸  Zwei Kunden mit gleichem DB können völlig unterschiedliche NMZ haben.</a:t>
+              <a:t>▸  Zwei Kunden mit gleichem DB können völlig unterschiedliche KNM haben.</a:t>
             </a:r>
           </a:p>
         </p:txBody>
@@ -10653,7 +10669,7 @@
                 </a:solidFill>
                 <a:latin typeface="Arial"/>
               </a:rPr>
-              <a:t>Der Nettomargenbeitrag (NMZ) im Aufbau</a:t>
+              <a:t>Der Kundennettomarge (KNM) im Aufbau</a:t>
             </a:r>
           </a:p>
         </p:txBody>
@@ -11093,7 +11109,7 @@
                 </a:solidFill>
                 <a:latin typeface="Arial"/>
               </a:rPr>
-              <a:t>Wo die NMZ-Daten herkommen</a:t>
+              <a:t>Wo die KNM-Daten herkommen</a:t>
             </a:r>
           </a:p>
         </p:txBody>
@@ -11135,7 +11151,7 @@
                 </a:solidFill>
                 <a:latin typeface="Arial"/>
               </a:rPr>
-              <a:t>→  Die NMZ liegt im agree-Reporting bereit – man muss das Ranking nur regelmäßig lesen.</a:t>
+              <a:t>→  Die KNM liegt im agree-Reporting bereit – man muss das Ranking nur regelmäßig lesen.</a:t>
             </a:r>
           </a:p>
           <a:p>
@@ -11154,7 +11170,7 @@
                 </a:solidFill>
                 <a:latin typeface="Arial"/>
               </a:rPr>
-              <a:t>▸  Das Bestandsranking zeigt jeden Kunden mit seiner NMZ und den Komponenten.</a:t>
+              <a:t>▸  Das Bestandsranking zeigt jeden Kunden mit seiner KNM und den Komponenten.</a:t>
             </a:r>
           </a:p>
           <a:p>
@@ -11425,7 +11441,7 @@
                 </a:solidFill>
                 <a:latin typeface="Arial"/>
               </a:rPr>
-              <a:t>Der NMZ-Optimierungsprozess</a:t>
+              <a:t>Der KNM-Optimierungsprozess</a:t>
             </a:r>
           </a:p>
         </p:txBody>

</xml_diff>